<commit_message>
Updated some tables and incorporated Stan implementation.
</commit_message>
<xml_diff>
--- a/manuscript/Figures/Analysis_Flowchart.pptx
+++ b/manuscript/Figures/Analysis_Flowchart.pptx
@@ -107,6 +107,11 @@
       </a:defRPr>
     </a:lvl9pPr>
   </p:defaultTextStyle>
+  <p:extLst>
+    <p:ext uri="{EFAFB233-063F-42B5-8137-9DF3F51BA10A}">
+      <p15:sldGuideLst xmlns:p15="http://schemas.microsoft.com/office/powerpoint/2012/main"/>
+    </p:ext>
+  </p:extLst>
 </p:presentation>
 </file>
 
@@ -192,7 +197,7 @@
           <a:p>
             <a:fld id="{E11D5B6E-E68A-4841-A3CE-3DC27AEF7D51}" type="datetimeFigureOut">
               <a:rPr lang="en-US" smtClean="0"/>
-              <a:t>12/29/25</a:t>
+              <a:t>6/19/26</a:t>
             </a:fld>
             <a:endParaRPr lang="en-US"/>
           </a:p>
@@ -690,7 +695,7 @@
           <a:p>
             <a:fld id="{D7780994-EACA-0440-8561-2CF35875F880}" type="datetimeFigureOut">
               <a:rPr lang="en-US" smtClean="0"/>
-              <a:t>12/29/25</a:t>
+              <a:t>6/19/26</a:t>
             </a:fld>
             <a:endParaRPr lang="en-US"/>
           </a:p>
@@ -888,7 +893,7 @@
           <a:p>
             <a:fld id="{D7780994-EACA-0440-8561-2CF35875F880}" type="datetimeFigureOut">
               <a:rPr lang="en-US" smtClean="0"/>
-              <a:t>12/29/25</a:t>
+              <a:t>6/19/26</a:t>
             </a:fld>
             <a:endParaRPr lang="en-US"/>
           </a:p>
@@ -1096,7 +1101,7 @@
           <a:p>
             <a:fld id="{D7780994-EACA-0440-8561-2CF35875F880}" type="datetimeFigureOut">
               <a:rPr lang="en-US" smtClean="0"/>
-              <a:t>12/29/25</a:t>
+              <a:t>6/19/26</a:t>
             </a:fld>
             <a:endParaRPr lang="en-US"/>
           </a:p>
@@ -1294,7 +1299,7 @@
           <a:p>
             <a:fld id="{D7780994-EACA-0440-8561-2CF35875F880}" type="datetimeFigureOut">
               <a:rPr lang="en-US" smtClean="0"/>
-              <a:t>12/29/25</a:t>
+              <a:t>6/19/26</a:t>
             </a:fld>
             <a:endParaRPr lang="en-US"/>
           </a:p>
@@ -1569,7 +1574,7 @@
           <a:p>
             <a:fld id="{D7780994-EACA-0440-8561-2CF35875F880}" type="datetimeFigureOut">
               <a:rPr lang="en-US" smtClean="0"/>
-              <a:t>12/29/25</a:t>
+              <a:t>6/19/26</a:t>
             </a:fld>
             <a:endParaRPr lang="en-US"/>
           </a:p>
@@ -1834,7 +1839,7 @@
           <a:p>
             <a:fld id="{D7780994-EACA-0440-8561-2CF35875F880}" type="datetimeFigureOut">
               <a:rPr lang="en-US" smtClean="0"/>
-              <a:t>12/29/25</a:t>
+              <a:t>6/19/26</a:t>
             </a:fld>
             <a:endParaRPr lang="en-US"/>
           </a:p>
@@ -2246,7 +2251,7 @@
           <a:p>
             <a:fld id="{D7780994-EACA-0440-8561-2CF35875F880}" type="datetimeFigureOut">
               <a:rPr lang="en-US" smtClean="0"/>
-              <a:t>12/29/25</a:t>
+              <a:t>6/19/26</a:t>
             </a:fld>
             <a:endParaRPr lang="en-US"/>
           </a:p>
@@ -2387,7 +2392,7 @@
           <a:p>
             <a:fld id="{D7780994-EACA-0440-8561-2CF35875F880}" type="datetimeFigureOut">
               <a:rPr lang="en-US" smtClean="0"/>
-              <a:t>12/29/25</a:t>
+              <a:t>6/19/26</a:t>
             </a:fld>
             <a:endParaRPr lang="en-US"/>
           </a:p>
@@ -2500,7 +2505,7 @@
           <a:p>
             <a:fld id="{D7780994-EACA-0440-8561-2CF35875F880}" type="datetimeFigureOut">
               <a:rPr lang="en-US" smtClean="0"/>
-              <a:t>12/29/25</a:t>
+              <a:t>6/19/26</a:t>
             </a:fld>
             <a:endParaRPr lang="en-US"/>
           </a:p>
@@ -2811,7 +2816,7 @@
           <a:p>
             <a:fld id="{D7780994-EACA-0440-8561-2CF35875F880}" type="datetimeFigureOut">
               <a:rPr lang="en-US" smtClean="0"/>
-              <a:t>12/29/25</a:t>
+              <a:t>6/19/26</a:t>
             </a:fld>
             <a:endParaRPr lang="en-US"/>
           </a:p>
@@ -3099,7 +3104,7 @@
           <a:p>
             <a:fld id="{D7780994-EACA-0440-8561-2CF35875F880}" type="datetimeFigureOut">
               <a:rPr lang="en-US" smtClean="0"/>
-              <a:t>12/29/25</a:t>
+              <a:t>6/19/26</a:t>
             </a:fld>
             <a:endParaRPr lang="en-US"/>
           </a:p>
@@ -3340,7 +3345,7 @@
           <a:p>
             <a:fld id="{D7780994-EACA-0440-8561-2CF35875F880}" type="datetimeFigureOut">
               <a:rPr lang="en-US" smtClean="0"/>
-              <a:t>12/29/25</a:t>
+              <a:t>6/19/26</a:t>
             </a:fld>
             <a:endParaRPr lang="en-US"/>
           </a:p>
@@ -3759,10 +3764,10 @@
       </p:grpSpPr>
       <p:grpSp>
         <p:nvGrpSpPr>
-          <p:cNvPr id="43" name="Group 42">
-            <a:extLst>
-              <a:ext uri="{FF2B5EF4-FFF2-40B4-BE49-F238E27FC236}">
-                <a16:creationId xmlns:a16="http://schemas.microsoft.com/office/drawing/2014/main" id="{B665437C-2032-ADF0-F213-09BF10299898}"/>
+          <p:cNvPr id="44" name="Group 43">
+            <a:extLst>
+              <a:ext uri="{FF2B5EF4-FFF2-40B4-BE49-F238E27FC236}">
+                <a16:creationId xmlns:a16="http://schemas.microsoft.com/office/drawing/2014/main" id="{BA804BE0-0B7E-33A6-AAA7-AF45FAAE20FE}"/>
               </a:ext>
             </a:extLst>
           </p:cNvPr>
@@ -3771,18 +3776,18 @@
         </p:nvGrpSpPr>
         <p:grpSpPr>
           <a:xfrm>
-            <a:off x="25213" y="100852"/>
-            <a:ext cx="11630584" cy="6659655"/>
-            <a:chOff x="25213" y="100852"/>
-            <a:chExt cx="11630584" cy="6659655"/>
+            <a:off x="2020729" y="1482167"/>
+            <a:ext cx="10115817" cy="3893664"/>
+            <a:chOff x="2020729" y="1482167"/>
+            <a:chExt cx="10115817" cy="3893664"/>
           </a:xfrm>
         </p:grpSpPr>
         <p:sp>
           <p:nvSpPr>
-            <p:cNvPr id="42" name="Rounded Rectangle 41">
+            <p:cNvPr id="45" name="Freeform 44">
               <a:extLst>
                 <a:ext uri="{FF2B5EF4-FFF2-40B4-BE49-F238E27FC236}">
-                  <a16:creationId xmlns:a16="http://schemas.microsoft.com/office/drawing/2014/main" id="{53AC1484-67DE-48F5-8865-D8BD81EB1AC3}"/>
+                  <a16:creationId xmlns:a16="http://schemas.microsoft.com/office/drawing/2014/main" id="{F6F163C4-7D63-0EE0-73D6-F5D4AA098CC3}"/>
                 </a:ext>
               </a:extLst>
             </p:cNvPr>
@@ -3791,56 +3796,164 @@
           </p:nvSpPr>
           <p:spPr>
             <a:xfrm>
-              <a:off x="25213" y="3688316"/>
-              <a:ext cx="11630584" cy="1337983"/>
+              <a:off x="2020729" y="1482167"/>
+              <a:ext cx="3084090" cy="771022"/>
             </a:xfrm>
-            <a:prstGeom prst="roundRect">
+            <a:custGeom>
               <a:avLst/>
-            </a:prstGeom>
-            <a:solidFill>
-              <a:schemeClr val="bg2">
-                <a:lumMod val="75000"/>
-              </a:schemeClr>
-            </a:solidFill>
-            <a:ln w="38100">
-              <a:noFill/>
-            </a:ln>
+              <a:gdLst>
+                <a:gd name="csX0" fmla="*/ 0 w 3084090"/>
+                <a:gd name="csY0" fmla="*/ 77102 h 771022"/>
+                <a:gd name="csX1" fmla="*/ 77102 w 3084090"/>
+                <a:gd name="csY1" fmla="*/ 0 h 771022"/>
+                <a:gd name="csX2" fmla="*/ 3006988 w 3084090"/>
+                <a:gd name="csY2" fmla="*/ 0 h 771022"/>
+                <a:gd name="csX3" fmla="*/ 3084090 w 3084090"/>
+                <a:gd name="csY3" fmla="*/ 77102 h 771022"/>
+                <a:gd name="csX4" fmla="*/ 3084090 w 3084090"/>
+                <a:gd name="csY4" fmla="*/ 693920 h 771022"/>
+                <a:gd name="csX5" fmla="*/ 3006988 w 3084090"/>
+                <a:gd name="csY5" fmla="*/ 771022 h 771022"/>
+                <a:gd name="csX6" fmla="*/ 77102 w 3084090"/>
+                <a:gd name="csY6" fmla="*/ 771022 h 771022"/>
+                <a:gd name="csX7" fmla="*/ 0 w 3084090"/>
+                <a:gd name="csY7" fmla="*/ 693920 h 771022"/>
+                <a:gd name="csX8" fmla="*/ 0 w 3084090"/>
+                <a:gd name="csY8" fmla="*/ 77102 h 771022"/>
+              </a:gdLst>
+              <a:ahLst/>
+              <a:cxnLst>
+                <a:cxn ang="0">
+                  <a:pos x="csX0" y="csY0"/>
+                </a:cxn>
+                <a:cxn ang="0">
+                  <a:pos x="csX1" y="csY1"/>
+                </a:cxn>
+                <a:cxn ang="0">
+                  <a:pos x="csX2" y="csY2"/>
+                </a:cxn>
+                <a:cxn ang="0">
+                  <a:pos x="csX3" y="csY3"/>
+                </a:cxn>
+                <a:cxn ang="0">
+                  <a:pos x="csX4" y="csY4"/>
+                </a:cxn>
+                <a:cxn ang="0">
+                  <a:pos x="csX5" y="csY5"/>
+                </a:cxn>
+                <a:cxn ang="0">
+                  <a:pos x="csX6" y="csY6"/>
+                </a:cxn>
+                <a:cxn ang="0">
+                  <a:pos x="csX7" y="csY7"/>
+                </a:cxn>
+                <a:cxn ang="0">
+                  <a:pos x="csX8" y="csY8"/>
+                </a:cxn>
+              </a:cxnLst>
+              <a:rect l="l" t="t" r="r" b="b"/>
+              <a:pathLst>
+                <a:path w="3084090" h="771022">
+                  <a:moveTo>
+                    <a:pt x="0" y="77102"/>
+                  </a:moveTo>
+                  <a:cubicBezTo>
+                    <a:pt x="0" y="34520"/>
+                    <a:pt x="34520" y="0"/>
+                    <a:pt x="77102" y="0"/>
+                  </a:cubicBezTo>
+                  <a:lnTo>
+                    <a:pt x="3006988" y="0"/>
+                  </a:lnTo>
+                  <a:cubicBezTo>
+                    <a:pt x="3049570" y="0"/>
+                    <a:pt x="3084090" y="34520"/>
+                    <a:pt x="3084090" y="77102"/>
+                  </a:cubicBezTo>
+                  <a:lnTo>
+                    <a:pt x="3084090" y="693920"/>
+                  </a:lnTo>
+                  <a:cubicBezTo>
+                    <a:pt x="3084090" y="736502"/>
+                    <a:pt x="3049570" y="771022"/>
+                    <a:pt x="3006988" y="771022"/>
+                  </a:cubicBezTo>
+                  <a:lnTo>
+                    <a:pt x="77102" y="771022"/>
+                  </a:lnTo>
+                  <a:cubicBezTo>
+                    <a:pt x="34520" y="771022"/>
+                    <a:pt x="0" y="736502"/>
+                    <a:pt x="0" y="693920"/>
+                  </a:cubicBezTo>
+                  <a:lnTo>
+                    <a:pt x="0" y="77102"/>
+                  </a:lnTo>
+                  <a:close/>
+                </a:path>
+              </a:pathLst>
+            </a:custGeom>
           </p:spPr>
           <p:style>
             <a:lnRef idx="2">
-              <a:schemeClr val="dk1"/>
+              <a:schemeClr val="lt2">
+                <a:hueOff val="0"/>
+                <a:satOff val="0"/>
+                <a:lumOff val="0"/>
+                <a:alphaOff val="0"/>
+              </a:schemeClr>
             </a:lnRef>
             <a:fillRef idx="1">
-              <a:schemeClr val="lt1"/>
+              <a:schemeClr val="dk2">
+                <a:hueOff val="0"/>
+                <a:satOff val="0"/>
+                <a:lumOff val="0"/>
+                <a:alphaOff val="0"/>
+              </a:schemeClr>
             </a:fillRef>
             <a:effectRef idx="0">
-              <a:schemeClr val="dk1"/>
+              <a:schemeClr val="dk2">
+                <a:hueOff val="0"/>
+                <a:satOff val="0"/>
+                <a:lumOff val="0"/>
+                <a:alphaOff val="0"/>
+              </a:schemeClr>
             </a:effectRef>
             <a:fontRef idx="minor">
-              <a:schemeClr val="dk1"/>
+              <a:schemeClr val="lt1"/>
             </a:fontRef>
           </p:style>
           <p:txBody>
-            <a:bodyPr rtlCol="0" anchor="ctr"/>
+            <a:bodyPr spcFirstLastPara="0" vert="horz" wrap="square" lIns="53062" tIns="53062" rIns="53062" bIns="53062" numCol="1" spcCol="1270" anchor="ctr" anchorCtr="0">
+              <a:noAutofit/>
+            </a:bodyPr>
             <a:lstStyle/>
             <a:p>
+              <a:pPr marL="0" lvl="0" indent="0" algn="ctr" defTabSz="1066800">
+                <a:lnSpc>
+                  <a:spcPct val="90000"/>
+                </a:lnSpc>
+                <a:spcBef>
+                  <a:spcPct val="0"/>
+                </a:spcBef>
+                <a:spcAft>
+                  <a:spcPct val="35000"/>
+                </a:spcAft>
+                <a:buNone/>
+              </a:pPr>
               <a:r>
-                <a:rPr lang="en-US" sz="2800" dirty="0">
-                  <a:solidFill>
-                    <a:schemeClr val="bg1"/>
-                  </a:solidFill>
-                </a:rPr>
-                <a:t>Parameter Initialization</a:t>
+                <a:rPr lang="en-US" sz="2400" kern="1200" dirty="0"/>
+                <a:t>Primary Analysis</a:t>
               </a:r>
             </a:p>
           </p:txBody>
         </p:sp>
         <p:sp>
           <p:nvSpPr>
-            <p:cNvPr id="38" name="Rounded Rectangle 37">
+            <p:cNvPr id="47" name="Freeform 46">
               <a:extLst>
                 <a:ext uri="{FF2B5EF4-FFF2-40B4-BE49-F238E27FC236}">
-                  <a16:creationId xmlns:a16="http://schemas.microsoft.com/office/drawing/2014/main" id="{8FB39DA2-FF86-0A33-402F-759A52A72852}"/>
+                  <a16:creationId xmlns:a16="http://schemas.microsoft.com/office/drawing/2014/main" id="{4DBC5011-270D-11AD-D70A-B0A20A1951FB}"/>
                 </a:ext>
               </a:extLst>
             </p:cNvPr>
@@ -3849,584 +3962,1634 @@
           </p:nvSpPr>
           <p:spPr>
             <a:xfrm>
-              <a:off x="25213" y="1826360"/>
-              <a:ext cx="11630584" cy="1337983"/>
+              <a:off x="2020729" y="2523048"/>
+              <a:ext cx="3084090" cy="771022"/>
             </a:xfrm>
-            <a:prstGeom prst="roundRect">
+            <a:custGeom>
               <a:avLst/>
-            </a:prstGeom>
-            <a:solidFill>
-              <a:schemeClr val="bg2">
-                <a:lumMod val="75000"/>
-              </a:schemeClr>
-            </a:solidFill>
-            <a:ln w="38100">
-              <a:noFill/>
-            </a:ln>
+              <a:gdLst>
+                <a:gd name="csX0" fmla="*/ 0 w 3084090"/>
+                <a:gd name="csY0" fmla="*/ 77102 h 771022"/>
+                <a:gd name="csX1" fmla="*/ 77102 w 3084090"/>
+                <a:gd name="csY1" fmla="*/ 0 h 771022"/>
+                <a:gd name="csX2" fmla="*/ 3006988 w 3084090"/>
+                <a:gd name="csY2" fmla="*/ 0 h 771022"/>
+                <a:gd name="csX3" fmla="*/ 3084090 w 3084090"/>
+                <a:gd name="csY3" fmla="*/ 77102 h 771022"/>
+                <a:gd name="csX4" fmla="*/ 3084090 w 3084090"/>
+                <a:gd name="csY4" fmla="*/ 693920 h 771022"/>
+                <a:gd name="csX5" fmla="*/ 3006988 w 3084090"/>
+                <a:gd name="csY5" fmla="*/ 771022 h 771022"/>
+                <a:gd name="csX6" fmla="*/ 77102 w 3084090"/>
+                <a:gd name="csY6" fmla="*/ 771022 h 771022"/>
+                <a:gd name="csX7" fmla="*/ 0 w 3084090"/>
+                <a:gd name="csY7" fmla="*/ 693920 h 771022"/>
+                <a:gd name="csX8" fmla="*/ 0 w 3084090"/>
+                <a:gd name="csY8" fmla="*/ 77102 h 771022"/>
+              </a:gdLst>
+              <a:ahLst/>
+              <a:cxnLst>
+                <a:cxn ang="0">
+                  <a:pos x="csX0" y="csY0"/>
+                </a:cxn>
+                <a:cxn ang="0">
+                  <a:pos x="csX1" y="csY1"/>
+                </a:cxn>
+                <a:cxn ang="0">
+                  <a:pos x="csX2" y="csY2"/>
+                </a:cxn>
+                <a:cxn ang="0">
+                  <a:pos x="csX3" y="csY3"/>
+                </a:cxn>
+                <a:cxn ang="0">
+                  <a:pos x="csX4" y="csY4"/>
+                </a:cxn>
+                <a:cxn ang="0">
+                  <a:pos x="csX5" y="csY5"/>
+                </a:cxn>
+                <a:cxn ang="0">
+                  <a:pos x="csX6" y="csY6"/>
+                </a:cxn>
+                <a:cxn ang="0">
+                  <a:pos x="csX7" y="csY7"/>
+                </a:cxn>
+                <a:cxn ang="0">
+                  <a:pos x="csX8" y="csY8"/>
+                </a:cxn>
+              </a:cxnLst>
+              <a:rect l="l" t="t" r="r" b="b"/>
+              <a:pathLst>
+                <a:path w="3084090" h="771022">
+                  <a:moveTo>
+                    <a:pt x="0" y="77102"/>
+                  </a:moveTo>
+                  <a:cubicBezTo>
+                    <a:pt x="0" y="34520"/>
+                    <a:pt x="34520" y="0"/>
+                    <a:pt x="77102" y="0"/>
+                  </a:cubicBezTo>
+                  <a:lnTo>
+                    <a:pt x="3006988" y="0"/>
+                  </a:lnTo>
+                  <a:cubicBezTo>
+                    <a:pt x="3049570" y="0"/>
+                    <a:pt x="3084090" y="34520"/>
+                    <a:pt x="3084090" y="77102"/>
+                  </a:cubicBezTo>
+                  <a:lnTo>
+                    <a:pt x="3084090" y="693920"/>
+                  </a:lnTo>
+                  <a:cubicBezTo>
+                    <a:pt x="3084090" y="736502"/>
+                    <a:pt x="3049570" y="771022"/>
+                    <a:pt x="3006988" y="771022"/>
+                  </a:cubicBezTo>
+                  <a:lnTo>
+                    <a:pt x="77102" y="771022"/>
+                  </a:lnTo>
+                  <a:cubicBezTo>
+                    <a:pt x="34520" y="771022"/>
+                    <a:pt x="0" y="736502"/>
+                    <a:pt x="0" y="693920"/>
+                  </a:cubicBezTo>
+                  <a:lnTo>
+                    <a:pt x="0" y="77102"/>
+                  </a:lnTo>
+                  <a:close/>
+                </a:path>
+              </a:pathLst>
+            </a:custGeom>
           </p:spPr>
           <p:style>
             <a:lnRef idx="2">
-              <a:schemeClr val="dk1"/>
+              <a:schemeClr val="dk2">
+                <a:alpha val="90000"/>
+                <a:tint val="40000"/>
+                <a:hueOff val="0"/>
+                <a:satOff val="0"/>
+                <a:lumOff val="0"/>
+                <a:alphaOff val="0"/>
+              </a:schemeClr>
             </a:lnRef>
             <a:fillRef idx="1">
-              <a:schemeClr val="lt1"/>
+              <a:schemeClr val="dk2">
+                <a:alpha val="90000"/>
+                <a:tint val="40000"/>
+                <a:hueOff val="0"/>
+                <a:satOff val="0"/>
+                <a:lumOff val="0"/>
+                <a:alphaOff val="0"/>
+              </a:schemeClr>
             </a:fillRef>
             <a:effectRef idx="0">
-              <a:schemeClr val="dk1"/>
+              <a:schemeClr val="dk2">
+                <a:alpha val="90000"/>
+                <a:tint val="40000"/>
+                <a:hueOff val="0"/>
+                <a:satOff val="0"/>
+                <a:lumOff val="0"/>
+                <a:alphaOff val="0"/>
+              </a:schemeClr>
             </a:effectRef>
             <a:fontRef idx="minor">
-              <a:schemeClr val="dk1"/>
+              <a:schemeClr val="dk1">
+                <a:hueOff val="0"/>
+                <a:satOff val="0"/>
+                <a:lumOff val="0"/>
+                <a:alphaOff val="0"/>
+              </a:schemeClr>
             </a:fontRef>
           </p:style>
           <p:txBody>
-            <a:bodyPr rtlCol="0" anchor="ctr"/>
+            <a:bodyPr spcFirstLastPara="0" vert="horz" wrap="square" lIns="53062" tIns="53062" rIns="53062" bIns="53062" numCol="1" spcCol="1270" anchor="ctr" anchorCtr="0">
+              <a:noAutofit/>
+            </a:bodyPr>
             <a:lstStyle/>
             <a:p>
+              <a:pPr marL="0" lvl="0" indent="0" algn="ctr" defTabSz="1066800">
+                <a:lnSpc>
+                  <a:spcPct val="90000"/>
+                </a:lnSpc>
+                <a:spcBef>
+                  <a:spcPct val="0"/>
+                </a:spcBef>
+                <a:spcAft>
+                  <a:spcPct val="35000"/>
+                </a:spcAft>
+                <a:buNone/>
+              </a:pPr>
               <a:r>
-                <a:rPr lang="en-US" sz="2800" dirty="0">
-                  <a:solidFill>
-                    <a:schemeClr val="bg1"/>
-                  </a:solidFill>
-                </a:rPr>
-                <a:t>Parameter Estimation</a:t>
+                <a:rPr lang="en-US" sz="2400" kern="1200" dirty="0"/>
+                <a:t>Common</a:t>
               </a:r>
             </a:p>
           </p:txBody>
         </p:sp>
-        <p:grpSp>
-          <p:nvGrpSpPr>
-            <p:cNvPr id="37" name="Group 36">
+        <p:sp>
+          <p:nvSpPr>
+            <p:cNvPr id="49" name="Freeform 48">
               <a:extLst>
                 <a:ext uri="{FF2B5EF4-FFF2-40B4-BE49-F238E27FC236}">
-                  <a16:creationId xmlns:a16="http://schemas.microsoft.com/office/drawing/2014/main" id="{84CE9EFA-05FC-6265-8034-BC9D631B8B44}"/>
+                  <a16:creationId xmlns:a16="http://schemas.microsoft.com/office/drawing/2014/main" id="{C934AE71-489F-3A6B-56B8-7554736C714E}"/>
                 </a:ext>
               </a:extLst>
             </p:cNvPr>
-            <p:cNvGrpSpPr/>
+            <p:cNvSpPr/>
             <p:nvPr/>
-          </p:nvGrpSpPr>
-          <p:grpSpPr>
+          </p:nvSpPr>
+          <p:spPr>
             <a:xfrm>
-              <a:off x="4401670" y="100852"/>
-              <a:ext cx="7169527" cy="6659655"/>
-              <a:chOff x="4657164" y="382779"/>
-              <a:chExt cx="7169527" cy="6659655"/>
+              <a:off x="2020729" y="3563928"/>
+              <a:ext cx="3084090" cy="771022"/>
             </a:xfrm>
-          </p:grpSpPr>
-          <p:sp>
-            <p:nvSpPr>
-              <p:cNvPr id="24" name="Rounded Rectangle 23">
-                <a:extLst>
-                  <a:ext uri="{FF2B5EF4-FFF2-40B4-BE49-F238E27FC236}">
-                    <a16:creationId xmlns:a16="http://schemas.microsoft.com/office/drawing/2014/main" id="{BF53D2A1-2FF1-DFD5-C77E-D52746B17861}"/>
-                  </a:ext>
-                </a:extLst>
-              </p:cNvPr>
-              <p:cNvSpPr/>
-              <p:nvPr/>
-            </p:nvSpPr>
-            <p:spPr>
-              <a:xfrm>
-                <a:off x="4657164" y="382779"/>
-                <a:ext cx="2877671" cy="1183341"/>
-              </a:xfrm>
-              <a:prstGeom prst="roundRect">
-                <a:avLst/>
-              </a:prstGeom>
-            </p:spPr>
-            <p:style>
-              <a:lnRef idx="2">
-                <a:schemeClr val="dk1"/>
-              </a:lnRef>
-              <a:fillRef idx="1">
-                <a:schemeClr val="lt1"/>
-              </a:fillRef>
-              <a:effectRef idx="0">
-                <a:schemeClr val="dk1"/>
-              </a:effectRef>
-              <a:fontRef idx="minor">
-                <a:schemeClr val="dk1"/>
-              </a:fontRef>
-            </p:style>
-            <p:txBody>
-              <a:bodyPr rtlCol="0" anchor="ctr"/>
-              <a:lstStyle/>
-              <a:p>
-                <a:pPr algn="ctr"/>
-                <a:r>
-                  <a:rPr lang="en-US" sz="2400" dirty="0"/>
-                  <a:t>Forward Model Estimates</a:t>
-                </a:r>
-              </a:p>
-            </p:txBody>
-          </p:sp>
-          <p:sp>
-            <p:nvSpPr>
-              <p:cNvPr id="25" name="Down Arrow 24">
-                <a:extLst>
-                  <a:ext uri="{FF2B5EF4-FFF2-40B4-BE49-F238E27FC236}">
-                    <a16:creationId xmlns:a16="http://schemas.microsoft.com/office/drawing/2014/main" id="{6BE81065-DB51-7520-2FFE-F107AEE1CC8B}"/>
-                  </a:ext>
-                </a:extLst>
-              </p:cNvPr>
-              <p:cNvSpPr/>
-              <p:nvPr/>
-            </p:nvSpPr>
-            <p:spPr>
-              <a:xfrm>
-                <a:off x="5977149" y="1627094"/>
-                <a:ext cx="237700" cy="443753"/>
-              </a:xfrm>
-              <a:prstGeom prst="downArrow">
-                <a:avLst/>
-              </a:prstGeom>
-            </p:spPr>
-            <p:style>
-              <a:lnRef idx="2">
-                <a:schemeClr val="dk1">
-                  <a:shade val="15000"/>
-                </a:schemeClr>
-              </a:lnRef>
-              <a:fillRef idx="1">
-                <a:schemeClr val="dk1"/>
-              </a:fillRef>
-              <a:effectRef idx="0">
-                <a:schemeClr val="dk1"/>
-              </a:effectRef>
-              <a:fontRef idx="minor">
-                <a:schemeClr val="lt1"/>
-              </a:fontRef>
-            </p:style>
-            <p:txBody>
-              <a:bodyPr rtlCol="0" anchor="ctr"/>
-              <a:lstStyle/>
-              <a:p>
-                <a:pPr algn="ctr"/>
-                <a:endParaRPr lang="en-US"/>
-              </a:p>
-            </p:txBody>
-          </p:sp>
-          <p:sp>
-            <p:nvSpPr>
-              <p:cNvPr id="26" name="Rounded Rectangle 25">
-                <a:extLst>
-                  <a:ext uri="{FF2B5EF4-FFF2-40B4-BE49-F238E27FC236}">
-                    <a16:creationId xmlns:a16="http://schemas.microsoft.com/office/drawing/2014/main" id="{B3B6D8E5-747F-81F1-C11D-2EFC0407971A}"/>
-                  </a:ext>
-                </a:extLst>
-              </p:cNvPr>
-              <p:cNvSpPr/>
-              <p:nvPr/>
-            </p:nvSpPr>
-            <p:spPr>
-              <a:xfrm>
-                <a:off x="4657164" y="2185609"/>
-                <a:ext cx="2877671" cy="1183341"/>
-              </a:xfrm>
-              <a:prstGeom prst="roundRect">
-                <a:avLst/>
-              </a:prstGeom>
-            </p:spPr>
-            <p:style>
-              <a:lnRef idx="2">
-                <a:schemeClr val="dk1"/>
-              </a:lnRef>
-              <a:fillRef idx="1">
-                <a:schemeClr val="lt1"/>
-              </a:fillRef>
-              <a:effectRef idx="0">
-                <a:schemeClr val="dk1"/>
-              </a:effectRef>
-              <a:fontRef idx="minor">
-                <a:schemeClr val="dk1"/>
-              </a:fontRef>
-            </p:style>
-            <p:txBody>
-              <a:bodyPr rtlCol="0" anchor="ctr"/>
-              <a:lstStyle/>
-              <a:p>
-                <a:pPr algn="ctr"/>
-                <a:r>
-                  <a:rPr lang="en-US" sz="2400" dirty="0"/>
-                  <a:t>Shared</a:t>
-                </a:r>
-              </a:p>
-            </p:txBody>
-          </p:sp>
-          <p:sp>
-            <p:nvSpPr>
-              <p:cNvPr id="27" name="Down Arrow 26">
-                <a:extLst>
-                  <a:ext uri="{FF2B5EF4-FFF2-40B4-BE49-F238E27FC236}">
-                    <a16:creationId xmlns:a16="http://schemas.microsoft.com/office/drawing/2014/main" id="{965A7819-AB22-A238-0203-5B76DF826EA2}"/>
-                  </a:ext>
-                </a:extLst>
-              </p:cNvPr>
-              <p:cNvSpPr/>
-              <p:nvPr/>
-            </p:nvSpPr>
-            <p:spPr>
-              <a:xfrm>
-                <a:off x="5977149" y="3483712"/>
-                <a:ext cx="237700" cy="443753"/>
-              </a:xfrm>
-              <a:prstGeom prst="downArrow">
-                <a:avLst/>
-              </a:prstGeom>
-            </p:spPr>
-            <p:style>
-              <a:lnRef idx="2">
-                <a:schemeClr val="dk1">
-                  <a:shade val="15000"/>
-                </a:schemeClr>
-              </a:lnRef>
-              <a:fillRef idx="1">
-                <a:schemeClr val="dk1"/>
-              </a:fillRef>
-              <a:effectRef idx="0">
-                <a:schemeClr val="dk1"/>
-              </a:effectRef>
-              <a:fontRef idx="minor">
-                <a:schemeClr val="lt1"/>
-              </a:fontRef>
-            </p:style>
-            <p:txBody>
-              <a:bodyPr rtlCol="0" anchor="ctr"/>
-              <a:lstStyle/>
-              <a:p>
-                <a:pPr algn="ctr"/>
-                <a:endParaRPr lang="en-US"/>
-              </a:p>
-            </p:txBody>
-          </p:sp>
-          <p:sp>
-            <p:nvSpPr>
-              <p:cNvPr id="28" name="Up-Down Arrow 27">
-                <a:extLst>
-                  <a:ext uri="{FF2B5EF4-FFF2-40B4-BE49-F238E27FC236}">
-                    <a16:creationId xmlns:a16="http://schemas.microsoft.com/office/drawing/2014/main" id="{674BD349-7633-7E65-3DE2-EB94801927C7}"/>
-                  </a:ext>
-                </a:extLst>
-              </p:cNvPr>
-              <p:cNvSpPr/>
-              <p:nvPr/>
-            </p:nvSpPr>
-            <p:spPr>
-              <a:xfrm rot="16200000">
-                <a:off x="8115498" y="2319812"/>
-                <a:ext cx="252859" cy="916645"/>
-              </a:xfrm>
-              <a:prstGeom prst="upDownArrow">
-                <a:avLst/>
-              </a:prstGeom>
-            </p:spPr>
-            <p:style>
-              <a:lnRef idx="2">
-                <a:schemeClr val="dk1">
-                  <a:shade val="15000"/>
-                </a:schemeClr>
-              </a:lnRef>
-              <a:fillRef idx="1">
-                <a:schemeClr val="dk1"/>
-              </a:fillRef>
-              <a:effectRef idx="0">
-                <a:schemeClr val="dk1"/>
-              </a:effectRef>
-              <a:fontRef idx="minor">
-                <a:schemeClr val="lt1"/>
-              </a:fontRef>
-            </p:style>
-            <p:txBody>
-              <a:bodyPr rtlCol="0" anchor="ctr"/>
-              <a:lstStyle/>
-              <a:p>
-                <a:pPr algn="ctr"/>
-                <a:endParaRPr lang="en-US"/>
-              </a:p>
-            </p:txBody>
-          </p:sp>
-          <p:sp>
-            <p:nvSpPr>
-              <p:cNvPr id="29" name="Rounded Rectangle 28">
-                <a:extLst>
-                  <a:ext uri="{FF2B5EF4-FFF2-40B4-BE49-F238E27FC236}">
-                    <a16:creationId xmlns:a16="http://schemas.microsoft.com/office/drawing/2014/main" id="{6C64E00F-88A9-0C84-6E13-E52FB853A27B}"/>
-                  </a:ext>
-                </a:extLst>
-              </p:cNvPr>
-              <p:cNvSpPr/>
-              <p:nvPr/>
-            </p:nvSpPr>
-            <p:spPr>
-              <a:xfrm>
-                <a:off x="8949020" y="2185609"/>
-                <a:ext cx="2877671" cy="1183341"/>
-              </a:xfrm>
-              <a:prstGeom prst="roundRect">
-                <a:avLst/>
-              </a:prstGeom>
-            </p:spPr>
-            <p:style>
-              <a:lnRef idx="2">
-                <a:schemeClr val="dk1"/>
-              </a:lnRef>
-              <a:fillRef idx="1">
-                <a:schemeClr val="lt1"/>
-              </a:fillRef>
-              <a:effectRef idx="0">
-                <a:schemeClr val="dk1"/>
-              </a:effectRef>
-              <a:fontRef idx="minor">
-                <a:schemeClr val="dk1"/>
-              </a:fontRef>
-            </p:style>
-            <p:txBody>
-              <a:bodyPr rtlCol="0" anchor="ctr"/>
-              <a:lstStyle/>
-              <a:p>
-                <a:pPr algn="ctr"/>
-                <a:r>
-                  <a:rPr lang="en-US" sz="2400" dirty="0"/>
-                  <a:t>Component-Specific</a:t>
-                </a:r>
-              </a:p>
-            </p:txBody>
-          </p:sp>
-          <p:sp>
-            <p:nvSpPr>
-              <p:cNvPr id="30" name="Rounded Rectangle 29">
-                <a:extLst>
-                  <a:ext uri="{FF2B5EF4-FFF2-40B4-BE49-F238E27FC236}">
-                    <a16:creationId xmlns:a16="http://schemas.microsoft.com/office/drawing/2014/main" id="{ED511037-7298-6A3B-61CD-4E0BF8FB5548}"/>
-                  </a:ext>
-                </a:extLst>
-              </p:cNvPr>
-              <p:cNvSpPr/>
-              <p:nvPr/>
-            </p:nvSpPr>
-            <p:spPr>
-              <a:xfrm>
-                <a:off x="4657164" y="4047565"/>
-                <a:ext cx="2877671" cy="1183341"/>
-              </a:xfrm>
-              <a:prstGeom prst="roundRect">
-                <a:avLst/>
-              </a:prstGeom>
-            </p:spPr>
-            <p:style>
-              <a:lnRef idx="2">
-                <a:schemeClr val="dk1"/>
-              </a:lnRef>
-              <a:fillRef idx="1">
-                <a:schemeClr val="lt1"/>
-              </a:fillRef>
-              <a:effectRef idx="0">
-                <a:schemeClr val="dk1"/>
-              </a:effectRef>
-              <a:fontRef idx="minor">
-                <a:schemeClr val="dk1"/>
-              </a:fontRef>
-            </p:style>
-            <p:txBody>
-              <a:bodyPr rtlCol="0" anchor="ctr"/>
-              <a:lstStyle/>
-              <a:p>
-                <a:pPr algn="ctr"/>
-                <a:r>
-                  <a:rPr lang="en-US" sz="2400" dirty="0"/>
-                  <a:t>Informed</a:t>
-                </a:r>
-              </a:p>
-            </p:txBody>
-          </p:sp>
-          <p:sp>
-            <p:nvSpPr>
-              <p:cNvPr id="31" name="Up-Down Arrow 30">
-                <a:extLst>
-                  <a:ext uri="{FF2B5EF4-FFF2-40B4-BE49-F238E27FC236}">
-                    <a16:creationId xmlns:a16="http://schemas.microsoft.com/office/drawing/2014/main" id="{D0658551-1913-9E54-A79E-CC718921F0C9}"/>
-                  </a:ext>
-                </a:extLst>
-              </p:cNvPr>
-              <p:cNvSpPr/>
-              <p:nvPr/>
-            </p:nvSpPr>
-            <p:spPr>
-              <a:xfrm rot="16200000">
-                <a:off x="8115498" y="4181768"/>
-                <a:ext cx="252859" cy="916645"/>
-              </a:xfrm>
-              <a:prstGeom prst="upDownArrow">
-                <a:avLst/>
-              </a:prstGeom>
-            </p:spPr>
-            <p:style>
-              <a:lnRef idx="2">
-                <a:schemeClr val="dk1">
-                  <a:shade val="15000"/>
-                </a:schemeClr>
-              </a:lnRef>
-              <a:fillRef idx="1">
-                <a:schemeClr val="dk1"/>
-              </a:fillRef>
-              <a:effectRef idx="0">
-                <a:schemeClr val="dk1"/>
-              </a:effectRef>
-              <a:fontRef idx="minor">
-                <a:schemeClr val="lt1"/>
-              </a:fontRef>
-            </p:style>
-            <p:txBody>
-              <a:bodyPr rtlCol="0" anchor="ctr"/>
-              <a:lstStyle/>
-              <a:p>
-                <a:pPr algn="ctr"/>
-                <a:endParaRPr lang="en-US"/>
-              </a:p>
-            </p:txBody>
-          </p:sp>
-          <p:sp>
-            <p:nvSpPr>
-              <p:cNvPr id="32" name="Rounded Rectangle 31">
-                <a:extLst>
-                  <a:ext uri="{FF2B5EF4-FFF2-40B4-BE49-F238E27FC236}">
-                    <a16:creationId xmlns:a16="http://schemas.microsoft.com/office/drawing/2014/main" id="{FBE9B0FE-1551-1225-0A6C-3387AAF19B8D}"/>
-                  </a:ext>
-                </a:extLst>
-              </p:cNvPr>
-              <p:cNvSpPr/>
-              <p:nvPr/>
-            </p:nvSpPr>
-            <p:spPr>
-              <a:xfrm>
-                <a:off x="8949020" y="4047565"/>
-                <a:ext cx="2877671" cy="1183341"/>
-              </a:xfrm>
-              <a:prstGeom prst="roundRect">
-                <a:avLst/>
-              </a:prstGeom>
-            </p:spPr>
-            <p:style>
-              <a:lnRef idx="2">
-                <a:schemeClr val="dk1"/>
-              </a:lnRef>
-              <a:fillRef idx="1">
-                <a:schemeClr val="lt1"/>
-              </a:fillRef>
-              <a:effectRef idx="0">
-                <a:schemeClr val="dk1"/>
-              </a:effectRef>
-              <a:fontRef idx="minor">
-                <a:schemeClr val="dk1"/>
-              </a:fontRef>
-            </p:style>
-            <p:txBody>
-              <a:bodyPr rtlCol="0" anchor="ctr"/>
-              <a:lstStyle/>
-              <a:p>
-                <a:pPr algn="ctr"/>
-                <a:r>
-                  <a:rPr lang="en-US" sz="2400" dirty="0"/>
-                  <a:t>Naive</a:t>
-                </a:r>
-              </a:p>
-            </p:txBody>
-          </p:sp>
-          <p:sp>
-            <p:nvSpPr>
-              <p:cNvPr id="33" name="Down Arrow 32">
-                <a:extLst>
-                  <a:ext uri="{FF2B5EF4-FFF2-40B4-BE49-F238E27FC236}">
-                    <a16:creationId xmlns:a16="http://schemas.microsoft.com/office/drawing/2014/main" id="{AA6D5ADE-9E33-5CBA-A41E-19AE3A2190F1}"/>
-                  </a:ext>
-                </a:extLst>
-              </p:cNvPr>
-              <p:cNvSpPr/>
-              <p:nvPr/>
-            </p:nvSpPr>
-            <p:spPr>
-              <a:xfrm>
-                <a:off x="5977149" y="5351006"/>
-                <a:ext cx="237700" cy="443753"/>
-              </a:xfrm>
-              <a:prstGeom prst="downArrow">
-                <a:avLst/>
-              </a:prstGeom>
-            </p:spPr>
-            <p:style>
-              <a:lnRef idx="2">
-                <a:schemeClr val="dk1">
-                  <a:shade val="15000"/>
-                </a:schemeClr>
-              </a:lnRef>
-              <a:fillRef idx="1">
-                <a:schemeClr val="dk1"/>
-              </a:fillRef>
-              <a:effectRef idx="0">
-                <a:schemeClr val="dk1"/>
-              </a:effectRef>
-              <a:fontRef idx="minor">
-                <a:schemeClr val="lt1"/>
-              </a:fontRef>
-            </p:style>
-            <p:txBody>
-              <a:bodyPr rtlCol="0" anchor="ctr"/>
-              <a:lstStyle/>
-              <a:p>
-                <a:pPr algn="ctr"/>
-                <a:endParaRPr lang="en-US"/>
-              </a:p>
-            </p:txBody>
-          </p:sp>
-          <p:sp>
-            <p:nvSpPr>
-              <p:cNvPr id="34" name="Rounded Rectangle 33">
-                <a:extLst>
-                  <a:ext uri="{FF2B5EF4-FFF2-40B4-BE49-F238E27FC236}">
-                    <a16:creationId xmlns:a16="http://schemas.microsoft.com/office/drawing/2014/main" id="{B5F94F61-FD7B-D159-C5C9-BDC96E36C152}"/>
-                  </a:ext>
-                </a:extLst>
-              </p:cNvPr>
-              <p:cNvSpPr/>
-              <p:nvPr/>
-            </p:nvSpPr>
-            <p:spPr>
-              <a:xfrm>
-                <a:off x="4657164" y="5859093"/>
-                <a:ext cx="2877671" cy="1183341"/>
-              </a:xfrm>
-              <a:prstGeom prst="roundRect">
-                <a:avLst/>
-              </a:prstGeom>
-            </p:spPr>
-            <p:style>
-              <a:lnRef idx="2">
-                <a:schemeClr val="dk1"/>
-              </a:lnRef>
-              <a:fillRef idx="1">
-                <a:schemeClr val="lt1"/>
-              </a:fillRef>
-              <a:effectRef idx="0">
-                <a:schemeClr val="dk1"/>
-              </a:effectRef>
-              <a:fontRef idx="minor">
-                <a:schemeClr val="dk1"/>
-              </a:fontRef>
-            </p:style>
-            <p:txBody>
-              <a:bodyPr rtlCol="0" anchor="ctr"/>
-              <a:lstStyle/>
-              <a:p>
-                <a:pPr algn="ctr"/>
-                <a:r>
-                  <a:rPr lang="en-US" sz="2400" dirty="0"/>
-                  <a:t>Simulation</a:t>
-                </a:r>
-              </a:p>
-            </p:txBody>
-          </p:sp>
-        </p:grpSp>
+            <a:custGeom>
+              <a:avLst/>
+              <a:gdLst>
+                <a:gd name="csX0" fmla="*/ 0 w 3084090"/>
+                <a:gd name="csY0" fmla="*/ 77102 h 771022"/>
+                <a:gd name="csX1" fmla="*/ 77102 w 3084090"/>
+                <a:gd name="csY1" fmla="*/ 0 h 771022"/>
+                <a:gd name="csX2" fmla="*/ 3006988 w 3084090"/>
+                <a:gd name="csY2" fmla="*/ 0 h 771022"/>
+                <a:gd name="csX3" fmla="*/ 3084090 w 3084090"/>
+                <a:gd name="csY3" fmla="*/ 77102 h 771022"/>
+                <a:gd name="csX4" fmla="*/ 3084090 w 3084090"/>
+                <a:gd name="csY4" fmla="*/ 693920 h 771022"/>
+                <a:gd name="csX5" fmla="*/ 3006988 w 3084090"/>
+                <a:gd name="csY5" fmla="*/ 771022 h 771022"/>
+                <a:gd name="csX6" fmla="*/ 77102 w 3084090"/>
+                <a:gd name="csY6" fmla="*/ 771022 h 771022"/>
+                <a:gd name="csX7" fmla="*/ 0 w 3084090"/>
+                <a:gd name="csY7" fmla="*/ 693920 h 771022"/>
+                <a:gd name="csX8" fmla="*/ 0 w 3084090"/>
+                <a:gd name="csY8" fmla="*/ 77102 h 771022"/>
+              </a:gdLst>
+              <a:ahLst/>
+              <a:cxnLst>
+                <a:cxn ang="0">
+                  <a:pos x="csX0" y="csY0"/>
+                </a:cxn>
+                <a:cxn ang="0">
+                  <a:pos x="csX1" y="csY1"/>
+                </a:cxn>
+                <a:cxn ang="0">
+                  <a:pos x="csX2" y="csY2"/>
+                </a:cxn>
+                <a:cxn ang="0">
+                  <a:pos x="csX3" y="csY3"/>
+                </a:cxn>
+                <a:cxn ang="0">
+                  <a:pos x="csX4" y="csY4"/>
+                </a:cxn>
+                <a:cxn ang="0">
+                  <a:pos x="csX5" y="csY5"/>
+                </a:cxn>
+                <a:cxn ang="0">
+                  <a:pos x="csX6" y="csY6"/>
+                </a:cxn>
+                <a:cxn ang="0">
+                  <a:pos x="csX7" y="csY7"/>
+                </a:cxn>
+                <a:cxn ang="0">
+                  <a:pos x="csX8" y="csY8"/>
+                </a:cxn>
+              </a:cxnLst>
+              <a:rect l="l" t="t" r="r" b="b"/>
+              <a:pathLst>
+                <a:path w="3084090" h="771022">
+                  <a:moveTo>
+                    <a:pt x="0" y="77102"/>
+                  </a:moveTo>
+                  <a:cubicBezTo>
+                    <a:pt x="0" y="34520"/>
+                    <a:pt x="34520" y="0"/>
+                    <a:pt x="77102" y="0"/>
+                  </a:cubicBezTo>
+                  <a:lnTo>
+                    <a:pt x="3006988" y="0"/>
+                  </a:lnTo>
+                  <a:cubicBezTo>
+                    <a:pt x="3049570" y="0"/>
+                    <a:pt x="3084090" y="34520"/>
+                    <a:pt x="3084090" y="77102"/>
+                  </a:cubicBezTo>
+                  <a:lnTo>
+                    <a:pt x="3084090" y="693920"/>
+                  </a:lnTo>
+                  <a:cubicBezTo>
+                    <a:pt x="3084090" y="736502"/>
+                    <a:pt x="3049570" y="771022"/>
+                    <a:pt x="3006988" y="771022"/>
+                  </a:cubicBezTo>
+                  <a:lnTo>
+                    <a:pt x="77102" y="771022"/>
+                  </a:lnTo>
+                  <a:cubicBezTo>
+                    <a:pt x="34520" y="771022"/>
+                    <a:pt x="0" y="736502"/>
+                    <a:pt x="0" y="693920"/>
+                  </a:cubicBezTo>
+                  <a:lnTo>
+                    <a:pt x="0" y="77102"/>
+                  </a:lnTo>
+                  <a:close/>
+                </a:path>
+              </a:pathLst>
+            </a:custGeom>
+          </p:spPr>
+          <p:style>
+            <a:lnRef idx="2">
+              <a:schemeClr val="dk2">
+                <a:alpha val="90000"/>
+                <a:tint val="40000"/>
+                <a:hueOff val="0"/>
+                <a:satOff val="0"/>
+                <a:lumOff val="0"/>
+                <a:alphaOff val="0"/>
+              </a:schemeClr>
+            </a:lnRef>
+            <a:fillRef idx="1">
+              <a:schemeClr val="dk2">
+                <a:alpha val="90000"/>
+                <a:tint val="40000"/>
+                <a:hueOff val="0"/>
+                <a:satOff val="0"/>
+                <a:lumOff val="0"/>
+                <a:alphaOff val="0"/>
+              </a:schemeClr>
+            </a:fillRef>
+            <a:effectRef idx="0">
+              <a:schemeClr val="dk2">
+                <a:alpha val="90000"/>
+                <a:tint val="40000"/>
+                <a:hueOff val="0"/>
+                <a:satOff val="0"/>
+                <a:lumOff val="0"/>
+                <a:alphaOff val="0"/>
+              </a:schemeClr>
+            </a:effectRef>
+            <a:fontRef idx="minor">
+              <a:schemeClr val="dk1">
+                <a:hueOff val="0"/>
+                <a:satOff val="0"/>
+                <a:lumOff val="0"/>
+                <a:alphaOff val="0"/>
+              </a:schemeClr>
+            </a:fontRef>
+          </p:style>
+          <p:txBody>
+            <a:bodyPr spcFirstLastPara="0" vert="horz" wrap="square" lIns="53062" tIns="53062" rIns="53062" bIns="53062" numCol="1" spcCol="1270" anchor="ctr" anchorCtr="0">
+              <a:noAutofit/>
+            </a:bodyPr>
+            <a:lstStyle/>
+            <a:p>
+              <a:pPr marL="0" lvl="0" indent="0" algn="ctr" defTabSz="1066800">
+                <a:lnSpc>
+                  <a:spcPct val="90000"/>
+                </a:lnSpc>
+                <a:spcBef>
+                  <a:spcPct val="0"/>
+                </a:spcBef>
+                <a:spcAft>
+                  <a:spcPct val="35000"/>
+                </a:spcAft>
+                <a:buNone/>
+              </a:pPr>
+              <a:r>
+                <a:rPr lang="en-US" sz="2400" kern="1200" dirty="0"/>
+                <a:t>Forward MLE</a:t>
+              </a:r>
+            </a:p>
+          </p:txBody>
+        </p:sp>
+        <p:sp>
+          <p:nvSpPr>
+            <p:cNvPr id="51" name="Freeform 50">
+              <a:extLst>
+                <a:ext uri="{FF2B5EF4-FFF2-40B4-BE49-F238E27FC236}">
+                  <a16:creationId xmlns:a16="http://schemas.microsoft.com/office/drawing/2014/main" id="{45CEA975-0A9B-8AAA-0001-0498BC078E05}"/>
+                </a:ext>
+              </a:extLst>
+            </p:cNvPr>
+            <p:cNvSpPr/>
+            <p:nvPr/>
+          </p:nvSpPr>
+          <p:spPr>
+            <a:xfrm>
+              <a:off x="2020729" y="4604809"/>
+              <a:ext cx="3084090" cy="771022"/>
+            </a:xfrm>
+            <a:custGeom>
+              <a:avLst/>
+              <a:gdLst>
+                <a:gd name="csX0" fmla="*/ 0 w 3084090"/>
+                <a:gd name="csY0" fmla="*/ 77102 h 771022"/>
+                <a:gd name="csX1" fmla="*/ 77102 w 3084090"/>
+                <a:gd name="csY1" fmla="*/ 0 h 771022"/>
+                <a:gd name="csX2" fmla="*/ 3006988 w 3084090"/>
+                <a:gd name="csY2" fmla="*/ 0 h 771022"/>
+                <a:gd name="csX3" fmla="*/ 3084090 w 3084090"/>
+                <a:gd name="csY3" fmla="*/ 77102 h 771022"/>
+                <a:gd name="csX4" fmla="*/ 3084090 w 3084090"/>
+                <a:gd name="csY4" fmla="*/ 693920 h 771022"/>
+                <a:gd name="csX5" fmla="*/ 3006988 w 3084090"/>
+                <a:gd name="csY5" fmla="*/ 771022 h 771022"/>
+                <a:gd name="csX6" fmla="*/ 77102 w 3084090"/>
+                <a:gd name="csY6" fmla="*/ 771022 h 771022"/>
+                <a:gd name="csX7" fmla="*/ 0 w 3084090"/>
+                <a:gd name="csY7" fmla="*/ 693920 h 771022"/>
+                <a:gd name="csX8" fmla="*/ 0 w 3084090"/>
+                <a:gd name="csY8" fmla="*/ 77102 h 771022"/>
+              </a:gdLst>
+              <a:ahLst/>
+              <a:cxnLst>
+                <a:cxn ang="0">
+                  <a:pos x="csX0" y="csY0"/>
+                </a:cxn>
+                <a:cxn ang="0">
+                  <a:pos x="csX1" y="csY1"/>
+                </a:cxn>
+                <a:cxn ang="0">
+                  <a:pos x="csX2" y="csY2"/>
+                </a:cxn>
+                <a:cxn ang="0">
+                  <a:pos x="csX3" y="csY3"/>
+                </a:cxn>
+                <a:cxn ang="0">
+                  <a:pos x="csX4" y="csY4"/>
+                </a:cxn>
+                <a:cxn ang="0">
+                  <a:pos x="csX5" y="csY5"/>
+                </a:cxn>
+                <a:cxn ang="0">
+                  <a:pos x="csX6" y="csY6"/>
+                </a:cxn>
+                <a:cxn ang="0">
+                  <a:pos x="csX7" y="csY7"/>
+                </a:cxn>
+                <a:cxn ang="0">
+                  <a:pos x="csX8" y="csY8"/>
+                </a:cxn>
+              </a:cxnLst>
+              <a:rect l="l" t="t" r="r" b="b"/>
+              <a:pathLst>
+                <a:path w="3084090" h="771022">
+                  <a:moveTo>
+                    <a:pt x="0" y="77102"/>
+                  </a:moveTo>
+                  <a:cubicBezTo>
+                    <a:pt x="0" y="34520"/>
+                    <a:pt x="34520" y="0"/>
+                    <a:pt x="77102" y="0"/>
+                  </a:cubicBezTo>
+                  <a:lnTo>
+                    <a:pt x="3006988" y="0"/>
+                  </a:lnTo>
+                  <a:cubicBezTo>
+                    <a:pt x="3049570" y="0"/>
+                    <a:pt x="3084090" y="34520"/>
+                    <a:pt x="3084090" y="77102"/>
+                  </a:cubicBezTo>
+                  <a:lnTo>
+                    <a:pt x="3084090" y="693920"/>
+                  </a:lnTo>
+                  <a:cubicBezTo>
+                    <a:pt x="3084090" y="736502"/>
+                    <a:pt x="3049570" y="771022"/>
+                    <a:pt x="3006988" y="771022"/>
+                  </a:cubicBezTo>
+                  <a:lnTo>
+                    <a:pt x="77102" y="771022"/>
+                  </a:lnTo>
+                  <a:cubicBezTo>
+                    <a:pt x="34520" y="771022"/>
+                    <a:pt x="0" y="736502"/>
+                    <a:pt x="0" y="693920"/>
+                  </a:cubicBezTo>
+                  <a:lnTo>
+                    <a:pt x="0" y="77102"/>
+                  </a:lnTo>
+                  <a:close/>
+                </a:path>
+              </a:pathLst>
+            </a:custGeom>
+          </p:spPr>
+          <p:style>
+            <a:lnRef idx="2">
+              <a:schemeClr val="dk2">
+                <a:alpha val="90000"/>
+                <a:tint val="40000"/>
+                <a:hueOff val="0"/>
+                <a:satOff val="0"/>
+                <a:lumOff val="0"/>
+                <a:alphaOff val="0"/>
+              </a:schemeClr>
+            </a:lnRef>
+            <a:fillRef idx="1">
+              <a:schemeClr val="dk2">
+                <a:alpha val="90000"/>
+                <a:tint val="40000"/>
+                <a:hueOff val="0"/>
+                <a:satOff val="0"/>
+                <a:lumOff val="0"/>
+                <a:alphaOff val="0"/>
+              </a:schemeClr>
+            </a:fillRef>
+            <a:effectRef idx="0">
+              <a:schemeClr val="dk2">
+                <a:alpha val="90000"/>
+                <a:tint val="40000"/>
+                <a:hueOff val="0"/>
+                <a:satOff val="0"/>
+                <a:lumOff val="0"/>
+                <a:alphaOff val="0"/>
+              </a:schemeClr>
+            </a:effectRef>
+            <a:fontRef idx="minor">
+              <a:schemeClr val="dk1">
+                <a:hueOff val="0"/>
+                <a:satOff val="0"/>
+                <a:lumOff val="0"/>
+                <a:alphaOff val="0"/>
+              </a:schemeClr>
+            </a:fontRef>
+          </p:style>
+          <p:txBody>
+            <a:bodyPr spcFirstLastPara="0" vert="horz" wrap="square" lIns="53062" tIns="53062" rIns="53062" bIns="53062" numCol="1" spcCol="1270" anchor="ctr" anchorCtr="0">
+              <a:noAutofit/>
+            </a:bodyPr>
+            <a:lstStyle/>
+            <a:p>
+              <a:pPr marL="0" lvl="0" indent="0" algn="ctr" defTabSz="1066800">
+                <a:lnSpc>
+                  <a:spcPct val="90000"/>
+                </a:lnSpc>
+                <a:spcBef>
+                  <a:spcPct val="0"/>
+                </a:spcBef>
+                <a:spcAft>
+                  <a:spcPct val="35000"/>
+                </a:spcAft>
+                <a:buNone/>
+              </a:pPr>
+              <a:r>
+                <a:rPr lang="en-US" sz="2400" kern="1200" dirty="0"/>
+                <a:t>Simulation</a:t>
+              </a:r>
+            </a:p>
+          </p:txBody>
+        </p:sp>
+        <p:sp>
+          <p:nvSpPr>
+            <p:cNvPr id="52" name="Freeform 51">
+              <a:extLst>
+                <a:ext uri="{FF2B5EF4-FFF2-40B4-BE49-F238E27FC236}">
+                  <a16:creationId xmlns:a16="http://schemas.microsoft.com/office/drawing/2014/main" id="{982A82ED-429D-1E10-C096-0A3FFD807A84}"/>
+                </a:ext>
+              </a:extLst>
+            </p:cNvPr>
+            <p:cNvSpPr/>
+            <p:nvPr/>
+          </p:nvSpPr>
+          <p:spPr>
+            <a:xfrm>
+              <a:off x="5536592" y="1482167"/>
+              <a:ext cx="3084090" cy="771022"/>
+            </a:xfrm>
+            <a:custGeom>
+              <a:avLst/>
+              <a:gdLst>
+                <a:gd name="csX0" fmla="*/ 0 w 3084090"/>
+                <a:gd name="csY0" fmla="*/ 77102 h 771022"/>
+                <a:gd name="csX1" fmla="*/ 77102 w 3084090"/>
+                <a:gd name="csY1" fmla="*/ 0 h 771022"/>
+                <a:gd name="csX2" fmla="*/ 3006988 w 3084090"/>
+                <a:gd name="csY2" fmla="*/ 0 h 771022"/>
+                <a:gd name="csX3" fmla="*/ 3084090 w 3084090"/>
+                <a:gd name="csY3" fmla="*/ 77102 h 771022"/>
+                <a:gd name="csX4" fmla="*/ 3084090 w 3084090"/>
+                <a:gd name="csY4" fmla="*/ 693920 h 771022"/>
+                <a:gd name="csX5" fmla="*/ 3006988 w 3084090"/>
+                <a:gd name="csY5" fmla="*/ 771022 h 771022"/>
+                <a:gd name="csX6" fmla="*/ 77102 w 3084090"/>
+                <a:gd name="csY6" fmla="*/ 771022 h 771022"/>
+                <a:gd name="csX7" fmla="*/ 0 w 3084090"/>
+                <a:gd name="csY7" fmla="*/ 693920 h 771022"/>
+                <a:gd name="csX8" fmla="*/ 0 w 3084090"/>
+                <a:gd name="csY8" fmla="*/ 77102 h 771022"/>
+              </a:gdLst>
+              <a:ahLst/>
+              <a:cxnLst>
+                <a:cxn ang="0">
+                  <a:pos x="csX0" y="csY0"/>
+                </a:cxn>
+                <a:cxn ang="0">
+                  <a:pos x="csX1" y="csY1"/>
+                </a:cxn>
+                <a:cxn ang="0">
+                  <a:pos x="csX2" y="csY2"/>
+                </a:cxn>
+                <a:cxn ang="0">
+                  <a:pos x="csX3" y="csY3"/>
+                </a:cxn>
+                <a:cxn ang="0">
+                  <a:pos x="csX4" y="csY4"/>
+                </a:cxn>
+                <a:cxn ang="0">
+                  <a:pos x="csX5" y="csY5"/>
+                </a:cxn>
+                <a:cxn ang="0">
+                  <a:pos x="csX6" y="csY6"/>
+                </a:cxn>
+                <a:cxn ang="0">
+                  <a:pos x="csX7" y="csY7"/>
+                </a:cxn>
+                <a:cxn ang="0">
+                  <a:pos x="csX8" y="csY8"/>
+                </a:cxn>
+              </a:cxnLst>
+              <a:rect l="l" t="t" r="r" b="b"/>
+              <a:pathLst>
+                <a:path w="3084090" h="771022">
+                  <a:moveTo>
+                    <a:pt x="0" y="77102"/>
+                  </a:moveTo>
+                  <a:cubicBezTo>
+                    <a:pt x="0" y="34520"/>
+                    <a:pt x="34520" y="0"/>
+                    <a:pt x="77102" y="0"/>
+                  </a:cubicBezTo>
+                  <a:lnTo>
+                    <a:pt x="3006988" y="0"/>
+                  </a:lnTo>
+                  <a:cubicBezTo>
+                    <a:pt x="3049570" y="0"/>
+                    <a:pt x="3084090" y="34520"/>
+                    <a:pt x="3084090" y="77102"/>
+                  </a:cubicBezTo>
+                  <a:lnTo>
+                    <a:pt x="3084090" y="693920"/>
+                  </a:lnTo>
+                  <a:cubicBezTo>
+                    <a:pt x="3084090" y="736502"/>
+                    <a:pt x="3049570" y="771022"/>
+                    <a:pt x="3006988" y="771022"/>
+                  </a:cubicBezTo>
+                  <a:lnTo>
+                    <a:pt x="77102" y="771022"/>
+                  </a:lnTo>
+                  <a:cubicBezTo>
+                    <a:pt x="34520" y="771022"/>
+                    <a:pt x="0" y="736502"/>
+                    <a:pt x="0" y="693920"/>
+                  </a:cubicBezTo>
+                  <a:lnTo>
+                    <a:pt x="0" y="77102"/>
+                  </a:lnTo>
+                  <a:close/>
+                </a:path>
+              </a:pathLst>
+            </a:custGeom>
+          </p:spPr>
+          <p:style>
+            <a:lnRef idx="2">
+              <a:schemeClr val="lt2">
+                <a:hueOff val="0"/>
+                <a:satOff val="0"/>
+                <a:lumOff val="0"/>
+                <a:alphaOff val="0"/>
+              </a:schemeClr>
+            </a:lnRef>
+            <a:fillRef idx="1">
+              <a:schemeClr val="dk2">
+                <a:hueOff val="0"/>
+                <a:satOff val="0"/>
+                <a:lumOff val="0"/>
+                <a:alphaOff val="0"/>
+              </a:schemeClr>
+            </a:fillRef>
+            <a:effectRef idx="0">
+              <a:schemeClr val="dk2">
+                <a:hueOff val="0"/>
+                <a:satOff val="0"/>
+                <a:lumOff val="0"/>
+                <a:alphaOff val="0"/>
+              </a:schemeClr>
+            </a:effectRef>
+            <a:fontRef idx="minor">
+              <a:schemeClr val="lt1"/>
+            </a:fontRef>
+          </p:style>
+          <p:txBody>
+            <a:bodyPr spcFirstLastPara="0" vert="horz" wrap="square" lIns="53062" tIns="53062" rIns="53062" bIns="53062" numCol="1" spcCol="1270" anchor="ctr" anchorCtr="0">
+              <a:noAutofit/>
+            </a:bodyPr>
+            <a:lstStyle/>
+            <a:p>
+              <a:pPr marL="0" lvl="0" indent="0" algn="ctr" defTabSz="1066800">
+                <a:lnSpc>
+                  <a:spcPct val="90000"/>
+                </a:lnSpc>
+                <a:spcBef>
+                  <a:spcPct val="0"/>
+                </a:spcBef>
+                <a:spcAft>
+                  <a:spcPct val="35000"/>
+                </a:spcAft>
+                <a:buNone/>
+              </a:pPr>
+              <a:r>
+                <a:rPr lang="en-US" sz="2400" kern="1200" dirty="0"/>
+                <a:t>Estimation Sensitivity</a:t>
+              </a:r>
+            </a:p>
+          </p:txBody>
+        </p:sp>
+        <p:sp>
+          <p:nvSpPr>
+            <p:cNvPr id="54" name="Freeform 53">
+              <a:extLst>
+                <a:ext uri="{FF2B5EF4-FFF2-40B4-BE49-F238E27FC236}">
+                  <a16:creationId xmlns:a16="http://schemas.microsoft.com/office/drawing/2014/main" id="{75149BD8-70B1-9915-1D34-64FE7F5C5BB8}"/>
+                </a:ext>
+              </a:extLst>
+            </p:cNvPr>
+            <p:cNvSpPr/>
+            <p:nvPr/>
+          </p:nvSpPr>
+          <p:spPr>
+            <a:xfrm>
+              <a:off x="5536592" y="2523048"/>
+              <a:ext cx="3084090" cy="771022"/>
+            </a:xfrm>
+            <a:custGeom>
+              <a:avLst/>
+              <a:gdLst>
+                <a:gd name="csX0" fmla="*/ 0 w 3084090"/>
+                <a:gd name="csY0" fmla="*/ 77102 h 771022"/>
+                <a:gd name="csX1" fmla="*/ 77102 w 3084090"/>
+                <a:gd name="csY1" fmla="*/ 0 h 771022"/>
+                <a:gd name="csX2" fmla="*/ 3006988 w 3084090"/>
+                <a:gd name="csY2" fmla="*/ 0 h 771022"/>
+                <a:gd name="csX3" fmla="*/ 3084090 w 3084090"/>
+                <a:gd name="csY3" fmla="*/ 77102 h 771022"/>
+                <a:gd name="csX4" fmla="*/ 3084090 w 3084090"/>
+                <a:gd name="csY4" fmla="*/ 693920 h 771022"/>
+                <a:gd name="csX5" fmla="*/ 3006988 w 3084090"/>
+                <a:gd name="csY5" fmla="*/ 771022 h 771022"/>
+                <a:gd name="csX6" fmla="*/ 77102 w 3084090"/>
+                <a:gd name="csY6" fmla="*/ 771022 h 771022"/>
+                <a:gd name="csX7" fmla="*/ 0 w 3084090"/>
+                <a:gd name="csY7" fmla="*/ 693920 h 771022"/>
+                <a:gd name="csX8" fmla="*/ 0 w 3084090"/>
+                <a:gd name="csY8" fmla="*/ 77102 h 771022"/>
+              </a:gdLst>
+              <a:ahLst/>
+              <a:cxnLst>
+                <a:cxn ang="0">
+                  <a:pos x="csX0" y="csY0"/>
+                </a:cxn>
+                <a:cxn ang="0">
+                  <a:pos x="csX1" y="csY1"/>
+                </a:cxn>
+                <a:cxn ang="0">
+                  <a:pos x="csX2" y="csY2"/>
+                </a:cxn>
+                <a:cxn ang="0">
+                  <a:pos x="csX3" y="csY3"/>
+                </a:cxn>
+                <a:cxn ang="0">
+                  <a:pos x="csX4" y="csY4"/>
+                </a:cxn>
+                <a:cxn ang="0">
+                  <a:pos x="csX5" y="csY5"/>
+                </a:cxn>
+                <a:cxn ang="0">
+                  <a:pos x="csX6" y="csY6"/>
+                </a:cxn>
+                <a:cxn ang="0">
+                  <a:pos x="csX7" y="csY7"/>
+                </a:cxn>
+                <a:cxn ang="0">
+                  <a:pos x="csX8" y="csY8"/>
+                </a:cxn>
+              </a:cxnLst>
+              <a:rect l="l" t="t" r="r" b="b"/>
+              <a:pathLst>
+                <a:path w="3084090" h="771022">
+                  <a:moveTo>
+                    <a:pt x="0" y="77102"/>
+                  </a:moveTo>
+                  <a:cubicBezTo>
+                    <a:pt x="0" y="34520"/>
+                    <a:pt x="34520" y="0"/>
+                    <a:pt x="77102" y="0"/>
+                  </a:cubicBezTo>
+                  <a:lnTo>
+                    <a:pt x="3006988" y="0"/>
+                  </a:lnTo>
+                  <a:cubicBezTo>
+                    <a:pt x="3049570" y="0"/>
+                    <a:pt x="3084090" y="34520"/>
+                    <a:pt x="3084090" y="77102"/>
+                  </a:cubicBezTo>
+                  <a:lnTo>
+                    <a:pt x="3084090" y="693920"/>
+                  </a:lnTo>
+                  <a:cubicBezTo>
+                    <a:pt x="3084090" y="736502"/>
+                    <a:pt x="3049570" y="771022"/>
+                    <a:pt x="3006988" y="771022"/>
+                  </a:cubicBezTo>
+                  <a:lnTo>
+                    <a:pt x="77102" y="771022"/>
+                  </a:lnTo>
+                  <a:cubicBezTo>
+                    <a:pt x="34520" y="771022"/>
+                    <a:pt x="0" y="736502"/>
+                    <a:pt x="0" y="693920"/>
+                  </a:cubicBezTo>
+                  <a:lnTo>
+                    <a:pt x="0" y="77102"/>
+                  </a:lnTo>
+                  <a:close/>
+                </a:path>
+              </a:pathLst>
+            </a:custGeom>
+          </p:spPr>
+          <p:style>
+            <a:lnRef idx="2">
+              <a:schemeClr val="dk2">
+                <a:alpha val="90000"/>
+                <a:tint val="40000"/>
+                <a:hueOff val="0"/>
+                <a:satOff val="0"/>
+                <a:lumOff val="0"/>
+                <a:alphaOff val="0"/>
+              </a:schemeClr>
+            </a:lnRef>
+            <a:fillRef idx="1">
+              <a:schemeClr val="dk2">
+                <a:alpha val="90000"/>
+                <a:tint val="40000"/>
+                <a:hueOff val="0"/>
+                <a:satOff val="0"/>
+                <a:lumOff val="0"/>
+                <a:alphaOff val="0"/>
+              </a:schemeClr>
+            </a:fillRef>
+            <a:effectRef idx="0">
+              <a:schemeClr val="dk2">
+                <a:alpha val="90000"/>
+                <a:tint val="40000"/>
+                <a:hueOff val="0"/>
+                <a:satOff val="0"/>
+                <a:lumOff val="0"/>
+                <a:alphaOff val="0"/>
+              </a:schemeClr>
+            </a:effectRef>
+            <a:fontRef idx="minor">
+              <a:schemeClr val="dk1">
+                <a:hueOff val="0"/>
+                <a:satOff val="0"/>
+                <a:lumOff val="0"/>
+                <a:alphaOff val="0"/>
+              </a:schemeClr>
+            </a:fontRef>
+          </p:style>
+          <p:txBody>
+            <a:bodyPr spcFirstLastPara="0" vert="horz" wrap="square" lIns="53062" tIns="53062" rIns="53062" bIns="53062" numCol="1" spcCol="1270" anchor="ctr" anchorCtr="0">
+              <a:noAutofit/>
+            </a:bodyPr>
+            <a:lstStyle/>
+            <a:p>
+              <a:pPr marL="0" lvl="0" indent="0" algn="ctr" defTabSz="1066800">
+                <a:lnSpc>
+                  <a:spcPct val="90000"/>
+                </a:lnSpc>
+                <a:spcBef>
+                  <a:spcPct val="0"/>
+                </a:spcBef>
+                <a:spcAft>
+                  <a:spcPct val="35000"/>
+                </a:spcAft>
+                <a:buNone/>
+              </a:pPr>
+              <a:r>
+                <a:rPr lang="en-US" sz="2400" kern="1200" dirty="0"/>
+                <a:t>Component-wise</a:t>
+              </a:r>
+            </a:p>
+          </p:txBody>
+        </p:sp>
+        <p:sp>
+          <p:nvSpPr>
+            <p:cNvPr id="56" name="Freeform 55">
+              <a:extLst>
+                <a:ext uri="{FF2B5EF4-FFF2-40B4-BE49-F238E27FC236}">
+                  <a16:creationId xmlns:a16="http://schemas.microsoft.com/office/drawing/2014/main" id="{15279FE6-955C-6D94-0049-864655BC8DB9}"/>
+                </a:ext>
+              </a:extLst>
+            </p:cNvPr>
+            <p:cNvSpPr/>
+            <p:nvPr/>
+          </p:nvSpPr>
+          <p:spPr>
+            <a:xfrm>
+              <a:off x="5536592" y="3563928"/>
+              <a:ext cx="3084090" cy="771022"/>
+            </a:xfrm>
+            <a:custGeom>
+              <a:avLst/>
+              <a:gdLst>
+                <a:gd name="csX0" fmla="*/ 0 w 3084090"/>
+                <a:gd name="csY0" fmla="*/ 77102 h 771022"/>
+                <a:gd name="csX1" fmla="*/ 77102 w 3084090"/>
+                <a:gd name="csY1" fmla="*/ 0 h 771022"/>
+                <a:gd name="csX2" fmla="*/ 3006988 w 3084090"/>
+                <a:gd name="csY2" fmla="*/ 0 h 771022"/>
+                <a:gd name="csX3" fmla="*/ 3084090 w 3084090"/>
+                <a:gd name="csY3" fmla="*/ 77102 h 771022"/>
+                <a:gd name="csX4" fmla="*/ 3084090 w 3084090"/>
+                <a:gd name="csY4" fmla="*/ 693920 h 771022"/>
+                <a:gd name="csX5" fmla="*/ 3006988 w 3084090"/>
+                <a:gd name="csY5" fmla="*/ 771022 h 771022"/>
+                <a:gd name="csX6" fmla="*/ 77102 w 3084090"/>
+                <a:gd name="csY6" fmla="*/ 771022 h 771022"/>
+                <a:gd name="csX7" fmla="*/ 0 w 3084090"/>
+                <a:gd name="csY7" fmla="*/ 693920 h 771022"/>
+                <a:gd name="csX8" fmla="*/ 0 w 3084090"/>
+                <a:gd name="csY8" fmla="*/ 77102 h 771022"/>
+              </a:gdLst>
+              <a:ahLst/>
+              <a:cxnLst>
+                <a:cxn ang="0">
+                  <a:pos x="csX0" y="csY0"/>
+                </a:cxn>
+                <a:cxn ang="0">
+                  <a:pos x="csX1" y="csY1"/>
+                </a:cxn>
+                <a:cxn ang="0">
+                  <a:pos x="csX2" y="csY2"/>
+                </a:cxn>
+                <a:cxn ang="0">
+                  <a:pos x="csX3" y="csY3"/>
+                </a:cxn>
+                <a:cxn ang="0">
+                  <a:pos x="csX4" y="csY4"/>
+                </a:cxn>
+                <a:cxn ang="0">
+                  <a:pos x="csX5" y="csY5"/>
+                </a:cxn>
+                <a:cxn ang="0">
+                  <a:pos x="csX6" y="csY6"/>
+                </a:cxn>
+                <a:cxn ang="0">
+                  <a:pos x="csX7" y="csY7"/>
+                </a:cxn>
+                <a:cxn ang="0">
+                  <a:pos x="csX8" y="csY8"/>
+                </a:cxn>
+              </a:cxnLst>
+              <a:rect l="l" t="t" r="r" b="b"/>
+              <a:pathLst>
+                <a:path w="3084090" h="771022">
+                  <a:moveTo>
+                    <a:pt x="0" y="77102"/>
+                  </a:moveTo>
+                  <a:cubicBezTo>
+                    <a:pt x="0" y="34520"/>
+                    <a:pt x="34520" y="0"/>
+                    <a:pt x="77102" y="0"/>
+                  </a:cubicBezTo>
+                  <a:lnTo>
+                    <a:pt x="3006988" y="0"/>
+                  </a:lnTo>
+                  <a:cubicBezTo>
+                    <a:pt x="3049570" y="0"/>
+                    <a:pt x="3084090" y="34520"/>
+                    <a:pt x="3084090" y="77102"/>
+                  </a:cubicBezTo>
+                  <a:lnTo>
+                    <a:pt x="3084090" y="693920"/>
+                  </a:lnTo>
+                  <a:cubicBezTo>
+                    <a:pt x="3084090" y="736502"/>
+                    <a:pt x="3049570" y="771022"/>
+                    <a:pt x="3006988" y="771022"/>
+                  </a:cubicBezTo>
+                  <a:lnTo>
+                    <a:pt x="77102" y="771022"/>
+                  </a:lnTo>
+                  <a:cubicBezTo>
+                    <a:pt x="34520" y="771022"/>
+                    <a:pt x="0" y="736502"/>
+                    <a:pt x="0" y="693920"/>
+                  </a:cubicBezTo>
+                  <a:lnTo>
+                    <a:pt x="0" y="77102"/>
+                  </a:lnTo>
+                  <a:close/>
+                </a:path>
+              </a:pathLst>
+            </a:custGeom>
+          </p:spPr>
+          <p:style>
+            <a:lnRef idx="2">
+              <a:schemeClr val="dk2">
+                <a:alpha val="90000"/>
+                <a:tint val="40000"/>
+                <a:hueOff val="0"/>
+                <a:satOff val="0"/>
+                <a:lumOff val="0"/>
+                <a:alphaOff val="0"/>
+              </a:schemeClr>
+            </a:lnRef>
+            <a:fillRef idx="1">
+              <a:schemeClr val="dk2">
+                <a:alpha val="90000"/>
+                <a:tint val="40000"/>
+                <a:hueOff val="0"/>
+                <a:satOff val="0"/>
+                <a:lumOff val="0"/>
+                <a:alphaOff val="0"/>
+              </a:schemeClr>
+            </a:fillRef>
+            <a:effectRef idx="0">
+              <a:schemeClr val="dk2">
+                <a:alpha val="90000"/>
+                <a:tint val="40000"/>
+                <a:hueOff val="0"/>
+                <a:satOff val="0"/>
+                <a:lumOff val="0"/>
+                <a:alphaOff val="0"/>
+              </a:schemeClr>
+            </a:effectRef>
+            <a:fontRef idx="minor">
+              <a:schemeClr val="dk1">
+                <a:hueOff val="0"/>
+                <a:satOff val="0"/>
+                <a:lumOff val="0"/>
+                <a:alphaOff val="0"/>
+              </a:schemeClr>
+            </a:fontRef>
+          </p:style>
+          <p:txBody>
+            <a:bodyPr spcFirstLastPara="0" vert="horz" wrap="square" lIns="53062" tIns="53062" rIns="53062" bIns="53062" numCol="1" spcCol="1270" anchor="ctr" anchorCtr="0">
+              <a:noAutofit/>
+            </a:bodyPr>
+            <a:lstStyle/>
+            <a:p>
+              <a:pPr marL="0" lvl="0" indent="0" algn="ctr" defTabSz="1066800">
+                <a:lnSpc>
+                  <a:spcPct val="90000"/>
+                </a:lnSpc>
+                <a:spcBef>
+                  <a:spcPct val="0"/>
+                </a:spcBef>
+                <a:spcAft>
+                  <a:spcPct val="35000"/>
+                </a:spcAft>
+                <a:buNone/>
+              </a:pPr>
+              <a:r>
+                <a:rPr lang="en-US" sz="2400" kern="1200" dirty="0"/>
+                <a:t>Forward MLE</a:t>
+              </a:r>
+            </a:p>
+          </p:txBody>
+        </p:sp>
+        <p:sp>
+          <p:nvSpPr>
+            <p:cNvPr id="57" name="Freeform 56">
+              <a:extLst>
+                <a:ext uri="{FF2B5EF4-FFF2-40B4-BE49-F238E27FC236}">
+                  <a16:creationId xmlns:a16="http://schemas.microsoft.com/office/drawing/2014/main" id="{6399FC21-37BB-B61A-042A-93985EA61307}"/>
+                </a:ext>
+              </a:extLst>
+            </p:cNvPr>
+            <p:cNvSpPr/>
+            <p:nvPr/>
+          </p:nvSpPr>
+          <p:spPr>
+            <a:xfrm>
+              <a:off x="9052456" y="1482167"/>
+              <a:ext cx="3084090" cy="771022"/>
+            </a:xfrm>
+            <a:custGeom>
+              <a:avLst/>
+              <a:gdLst>
+                <a:gd name="csX0" fmla="*/ 0 w 3084090"/>
+                <a:gd name="csY0" fmla="*/ 77102 h 771022"/>
+                <a:gd name="csX1" fmla="*/ 77102 w 3084090"/>
+                <a:gd name="csY1" fmla="*/ 0 h 771022"/>
+                <a:gd name="csX2" fmla="*/ 3006988 w 3084090"/>
+                <a:gd name="csY2" fmla="*/ 0 h 771022"/>
+                <a:gd name="csX3" fmla="*/ 3084090 w 3084090"/>
+                <a:gd name="csY3" fmla="*/ 77102 h 771022"/>
+                <a:gd name="csX4" fmla="*/ 3084090 w 3084090"/>
+                <a:gd name="csY4" fmla="*/ 693920 h 771022"/>
+                <a:gd name="csX5" fmla="*/ 3006988 w 3084090"/>
+                <a:gd name="csY5" fmla="*/ 771022 h 771022"/>
+                <a:gd name="csX6" fmla="*/ 77102 w 3084090"/>
+                <a:gd name="csY6" fmla="*/ 771022 h 771022"/>
+                <a:gd name="csX7" fmla="*/ 0 w 3084090"/>
+                <a:gd name="csY7" fmla="*/ 693920 h 771022"/>
+                <a:gd name="csX8" fmla="*/ 0 w 3084090"/>
+                <a:gd name="csY8" fmla="*/ 77102 h 771022"/>
+              </a:gdLst>
+              <a:ahLst/>
+              <a:cxnLst>
+                <a:cxn ang="0">
+                  <a:pos x="csX0" y="csY0"/>
+                </a:cxn>
+                <a:cxn ang="0">
+                  <a:pos x="csX1" y="csY1"/>
+                </a:cxn>
+                <a:cxn ang="0">
+                  <a:pos x="csX2" y="csY2"/>
+                </a:cxn>
+                <a:cxn ang="0">
+                  <a:pos x="csX3" y="csY3"/>
+                </a:cxn>
+                <a:cxn ang="0">
+                  <a:pos x="csX4" y="csY4"/>
+                </a:cxn>
+                <a:cxn ang="0">
+                  <a:pos x="csX5" y="csY5"/>
+                </a:cxn>
+                <a:cxn ang="0">
+                  <a:pos x="csX6" y="csY6"/>
+                </a:cxn>
+                <a:cxn ang="0">
+                  <a:pos x="csX7" y="csY7"/>
+                </a:cxn>
+                <a:cxn ang="0">
+                  <a:pos x="csX8" y="csY8"/>
+                </a:cxn>
+              </a:cxnLst>
+              <a:rect l="l" t="t" r="r" b="b"/>
+              <a:pathLst>
+                <a:path w="3084090" h="771022">
+                  <a:moveTo>
+                    <a:pt x="0" y="77102"/>
+                  </a:moveTo>
+                  <a:cubicBezTo>
+                    <a:pt x="0" y="34520"/>
+                    <a:pt x="34520" y="0"/>
+                    <a:pt x="77102" y="0"/>
+                  </a:cubicBezTo>
+                  <a:lnTo>
+                    <a:pt x="3006988" y="0"/>
+                  </a:lnTo>
+                  <a:cubicBezTo>
+                    <a:pt x="3049570" y="0"/>
+                    <a:pt x="3084090" y="34520"/>
+                    <a:pt x="3084090" y="77102"/>
+                  </a:cubicBezTo>
+                  <a:lnTo>
+                    <a:pt x="3084090" y="693920"/>
+                  </a:lnTo>
+                  <a:cubicBezTo>
+                    <a:pt x="3084090" y="736502"/>
+                    <a:pt x="3049570" y="771022"/>
+                    <a:pt x="3006988" y="771022"/>
+                  </a:cubicBezTo>
+                  <a:lnTo>
+                    <a:pt x="77102" y="771022"/>
+                  </a:lnTo>
+                  <a:cubicBezTo>
+                    <a:pt x="34520" y="771022"/>
+                    <a:pt x="0" y="736502"/>
+                    <a:pt x="0" y="693920"/>
+                  </a:cubicBezTo>
+                  <a:lnTo>
+                    <a:pt x="0" y="77102"/>
+                  </a:lnTo>
+                  <a:close/>
+                </a:path>
+              </a:pathLst>
+            </a:custGeom>
+          </p:spPr>
+          <p:style>
+            <a:lnRef idx="2">
+              <a:schemeClr val="lt2">
+                <a:hueOff val="0"/>
+                <a:satOff val="0"/>
+                <a:lumOff val="0"/>
+                <a:alphaOff val="0"/>
+              </a:schemeClr>
+            </a:lnRef>
+            <a:fillRef idx="1">
+              <a:schemeClr val="dk2">
+                <a:hueOff val="0"/>
+                <a:satOff val="0"/>
+                <a:lumOff val="0"/>
+                <a:alphaOff val="0"/>
+              </a:schemeClr>
+            </a:fillRef>
+            <a:effectRef idx="0">
+              <a:schemeClr val="dk2">
+                <a:hueOff val="0"/>
+                <a:satOff val="0"/>
+                <a:lumOff val="0"/>
+                <a:alphaOff val="0"/>
+              </a:schemeClr>
+            </a:effectRef>
+            <a:fontRef idx="minor">
+              <a:schemeClr val="lt1"/>
+            </a:fontRef>
+          </p:style>
+          <p:txBody>
+            <a:bodyPr spcFirstLastPara="0" vert="horz" wrap="square" lIns="53062" tIns="53062" rIns="53062" bIns="53062" numCol="1" spcCol="1270" anchor="ctr" anchorCtr="0">
+              <a:noAutofit/>
+            </a:bodyPr>
+            <a:lstStyle/>
+            <a:p>
+              <a:pPr marL="0" lvl="0" indent="0" algn="ctr" defTabSz="1066800">
+                <a:lnSpc>
+                  <a:spcPct val="90000"/>
+                </a:lnSpc>
+                <a:spcBef>
+                  <a:spcPct val="0"/>
+                </a:spcBef>
+                <a:spcAft>
+                  <a:spcPct val="35000"/>
+                </a:spcAft>
+                <a:buNone/>
+              </a:pPr>
+              <a:r>
+                <a:rPr lang="en-US" sz="2400" kern="1200" dirty="0"/>
+                <a:t>Initialization Sensitivity</a:t>
+              </a:r>
+            </a:p>
+          </p:txBody>
+        </p:sp>
+        <p:sp>
+          <p:nvSpPr>
+            <p:cNvPr id="59" name="Freeform 58">
+              <a:extLst>
+                <a:ext uri="{FF2B5EF4-FFF2-40B4-BE49-F238E27FC236}">
+                  <a16:creationId xmlns:a16="http://schemas.microsoft.com/office/drawing/2014/main" id="{77591458-190F-0FDF-23A0-CAD1A43968D5}"/>
+                </a:ext>
+              </a:extLst>
+            </p:cNvPr>
+            <p:cNvSpPr/>
+            <p:nvPr/>
+          </p:nvSpPr>
+          <p:spPr>
+            <a:xfrm>
+              <a:off x="9052456" y="2523048"/>
+              <a:ext cx="3084090" cy="771022"/>
+            </a:xfrm>
+            <a:custGeom>
+              <a:avLst/>
+              <a:gdLst>
+                <a:gd name="csX0" fmla="*/ 0 w 3084090"/>
+                <a:gd name="csY0" fmla="*/ 77102 h 771022"/>
+                <a:gd name="csX1" fmla="*/ 77102 w 3084090"/>
+                <a:gd name="csY1" fmla="*/ 0 h 771022"/>
+                <a:gd name="csX2" fmla="*/ 3006988 w 3084090"/>
+                <a:gd name="csY2" fmla="*/ 0 h 771022"/>
+                <a:gd name="csX3" fmla="*/ 3084090 w 3084090"/>
+                <a:gd name="csY3" fmla="*/ 77102 h 771022"/>
+                <a:gd name="csX4" fmla="*/ 3084090 w 3084090"/>
+                <a:gd name="csY4" fmla="*/ 693920 h 771022"/>
+                <a:gd name="csX5" fmla="*/ 3006988 w 3084090"/>
+                <a:gd name="csY5" fmla="*/ 771022 h 771022"/>
+                <a:gd name="csX6" fmla="*/ 77102 w 3084090"/>
+                <a:gd name="csY6" fmla="*/ 771022 h 771022"/>
+                <a:gd name="csX7" fmla="*/ 0 w 3084090"/>
+                <a:gd name="csY7" fmla="*/ 693920 h 771022"/>
+                <a:gd name="csX8" fmla="*/ 0 w 3084090"/>
+                <a:gd name="csY8" fmla="*/ 77102 h 771022"/>
+              </a:gdLst>
+              <a:ahLst/>
+              <a:cxnLst>
+                <a:cxn ang="0">
+                  <a:pos x="csX0" y="csY0"/>
+                </a:cxn>
+                <a:cxn ang="0">
+                  <a:pos x="csX1" y="csY1"/>
+                </a:cxn>
+                <a:cxn ang="0">
+                  <a:pos x="csX2" y="csY2"/>
+                </a:cxn>
+                <a:cxn ang="0">
+                  <a:pos x="csX3" y="csY3"/>
+                </a:cxn>
+                <a:cxn ang="0">
+                  <a:pos x="csX4" y="csY4"/>
+                </a:cxn>
+                <a:cxn ang="0">
+                  <a:pos x="csX5" y="csY5"/>
+                </a:cxn>
+                <a:cxn ang="0">
+                  <a:pos x="csX6" y="csY6"/>
+                </a:cxn>
+                <a:cxn ang="0">
+                  <a:pos x="csX7" y="csY7"/>
+                </a:cxn>
+                <a:cxn ang="0">
+                  <a:pos x="csX8" y="csY8"/>
+                </a:cxn>
+              </a:cxnLst>
+              <a:rect l="l" t="t" r="r" b="b"/>
+              <a:pathLst>
+                <a:path w="3084090" h="771022">
+                  <a:moveTo>
+                    <a:pt x="0" y="77102"/>
+                  </a:moveTo>
+                  <a:cubicBezTo>
+                    <a:pt x="0" y="34520"/>
+                    <a:pt x="34520" y="0"/>
+                    <a:pt x="77102" y="0"/>
+                  </a:cubicBezTo>
+                  <a:lnTo>
+                    <a:pt x="3006988" y="0"/>
+                  </a:lnTo>
+                  <a:cubicBezTo>
+                    <a:pt x="3049570" y="0"/>
+                    <a:pt x="3084090" y="34520"/>
+                    <a:pt x="3084090" y="77102"/>
+                  </a:cubicBezTo>
+                  <a:lnTo>
+                    <a:pt x="3084090" y="693920"/>
+                  </a:lnTo>
+                  <a:cubicBezTo>
+                    <a:pt x="3084090" y="736502"/>
+                    <a:pt x="3049570" y="771022"/>
+                    <a:pt x="3006988" y="771022"/>
+                  </a:cubicBezTo>
+                  <a:lnTo>
+                    <a:pt x="77102" y="771022"/>
+                  </a:lnTo>
+                  <a:cubicBezTo>
+                    <a:pt x="34520" y="771022"/>
+                    <a:pt x="0" y="736502"/>
+                    <a:pt x="0" y="693920"/>
+                  </a:cubicBezTo>
+                  <a:lnTo>
+                    <a:pt x="0" y="77102"/>
+                  </a:lnTo>
+                  <a:close/>
+                </a:path>
+              </a:pathLst>
+            </a:custGeom>
+          </p:spPr>
+          <p:style>
+            <a:lnRef idx="2">
+              <a:schemeClr val="dk2">
+                <a:alpha val="90000"/>
+                <a:tint val="40000"/>
+                <a:hueOff val="0"/>
+                <a:satOff val="0"/>
+                <a:lumOff val="0"/>
+                <a:alphaOff val="0"/>
+              </a:schemeClr>
+            </a:lnRef>
+            <a:fillRef idx="1">
+              <a:schemeClr val="dk2">
+                <a:alpha val="90000"/>
+                <a:tint val="40000"/>
+                <a:hueOff val="0"/>
+                <a:satOff val="0"/>
+                <a:lumOff val="0"/>
+                <a:alphaOff val="0"/>
+              </a:schemeClr>
+            </a:fillRef>
+            <a:effectRef idx="0">
+              <a:schemeClr val="dk2">
+                <a:alpha val="90000"/>
+                <a:tint val="40000"/>
+                <a:hueOff val="0"/>
+                <a:satOff val="0"/>
+                <a:lumOff val="0"/>
+                <a:alphaOff val="0"/>
+              </a:schemeClr>
+            </a:effectRef>
+            <a:fontRef idx="minor">
+              <a:schemeClr val="dk1">
+                <a:hueOff val="0"/>
+                <a:satOff val="0"/>
+                <a:lumOff val="0"/>
+                <a:alphaOff val="0"/>
+              </a:schemeClr>
+            </a:fontRef>
+          </p:style>
+          <p:txBody>
+            <a:bodyPr spcFirstLastPara="0" vert="horz" wrap="square" lIns="53062" tIns="53062" rIns="53062" bIns="53062" numCol="1" spcCol="1270" anchor="ctr" anchorCtr="0">
+              <a:noAutofit/>
+            </a:bodyPr>
+            <a:lstStyle/>
+            <a:p>
+              <a:pPr marL="0" lvl="0" indent="0" algn="ctr" defTabSz="1066800">
+                <a:lnSpc>
+                  <a:spcPct val="90000"/>
+                </a:lnSpc>
+                <a:spcBef>
+                  <a:spcPct val="0"/>
+                </a:spcBef>
+                <a:spcAft>
+                  <a:spcPct val="35000"/>
+                </a:spcAft>
+                <a:buNone/>
+              </a:pPr>
+              <a:r>
+                <a:rPr lang="en-US" sz="2400" kern="1200" dirty="0"/>
+                <a:t>Common</a:t>
+              </a:r>
+            </a:p>
+          </p:txBody>
+        </p:sp>
+        <p:sp>
+          <p:nvSpPr>
+            <p:cNvPr id="61" name="Freeform 60">
+              <a:extLst>
+                <a:ext uri="{FF2B5EF4-FFF2-40B4-BE49-F238E27FC236}">
+                  <a16:creationId xmlns:a16="http://schemas.microsoft.com/office/drawing/2014/main" id="{3D680EC1-2920-A317-728B-A93F99DCE10A}"/>
+                </a:ext>
+              </a:extLst>
+            </p:cNvPr>
+            <p:cNvSpPr/>
+            <p:nvPr/>
+          </p:nvSpPr>
+          <p:spPr>
+            <a:xfrm>
+              <a:off x="9052456" y="3563928"/>
+              <a:ext cx="3084090" cy="771022"/>
+            </a:xfrm>
+            <a:custGeom>
+              <a:avLst/>
+              <a:gdLst>
+                <a:gd name="csX0" fmla="*/ 0 w 3084090"/>
+                <a:gd name="csY0" fmla="*/ 77102 h 771022"/>
+                <a:gd name="csX1" fmla="*/ 77102 w 3084090"/>
+                <a:gd name="csY1" fmla="*/ 0 h 771022"/>
+                <a:gd name="csX2" fmla="*/ 3006988 w 3084090"/>
+                <a:gd name="csY2" fmla="*/ 0 h 771022"/>
+                <a:gd name="csX3" fmla="*/ 3084090 w 3084090"/>
+                <a:gd name="csY3" fmla="*/ 77102 h 771022"/>
+                <a:gd name="csX4" fmla="*/ 3084090 w 3084090"/>
+                <a:gd name="csY4" fmla="*/ 693920 h 771022"/>
+                <a:gd name="csX5" fmla="*/ 3006988 w 3084090"/>
+                <a:gd name="csY5" fmla="*/ 771022 h 771022"/>
+                <a:gd name="csX6" fmla="*/ 77102 w 3084090"/>
+                <a:gd name="csY6" fmla="*/ 771022 h 771022"/>
+                <a:gd name="csX7" fmla="*/ 0 w 3084090"/>
+                <a:gd name="csY7" fmla="*/ 693920 h 771022"/>
+                <a:gd name="csX8" fmla="*/ 0 w 3084090"/>
+                <a:gd name="csY8" fmla="*/ 77102 h 771022"/>
+              </a:gdLst>
+              <a:ahLst/>
+              <a:cxnLst>
+                <a:cxn ang="0">
+                  <a:pos x="csX0" y="csY0"/>
+                </a:cxn>
+                <a:cxn ang="0">
+                  <a:pos x="csX1" y="csY1"/>
+                </a:cxn>
+                <a:cxn ang="0">
+                  <a:pos x="csX2" y="csY2"/>
+                </a:cxn>
+                <a:cxn ang="0">
+                  <a:pos x="csX3" y="csY3"/>
+                </a:cxn>
+                <a:cxn ang="0">
+                  <a:pos x="csX4" y="csY4"/>
+                </a:cxn>
+                <a:cxn ang="0">
+                  <a:pos x="csX5" y="csY5"/>
+                </a:cxn>
+                <a:cxn ang="0">
+                  <a:pos x="csX6" y="csY6"/>
+                </a:cxn>
+                <a:cxn ang="0">
+                  <a:pos x="csX7" y="csY7"/>
+                </a:cxn>
+                <a:cxn ang="0">
+                  <a:pos x="csX8" y="csY8"/>
+                </a:cxn>
+              </a:cxnLst>
+              <a:rect l="l" t="t" r="r" b="b"/>
+              <a:pathLst>
+                <a:path w="3084090" h="771022">
+                  <a:moveTo>
+                    <a:pt x="0" y="77102"/>
+                  </a:moveTo>
+                  <a:cubicBezTo>
+                    <a:pt x="0" y="34520"/>
+                    <a:pt x="34520" y="0"/>
+                    <a:pt x="77102" y="0"/>
+                  </a:cubicBezTo>
+                  <a:lnTo>
+                    <a:pt x="3006988" y="0"/>
+                  </a:lnTo>
+                  <a:cubicBezTo>
+                    <a:pt x="3049570" y="0"/>
+                    <a:pt x="3084090" y="34520"/>
+                    <a:pt x="3084090" y="77102"/>
+                  </a:cubicBezTo>
+                  <a:lnTo>
+                    <a:pt x="3084090" y="693920"/>
+                  </a:lnTo>
+                  <a:cubicBezTo>
+                    <a:pt x="3084090" y="736502"/>
+                    <a:pt x="3049570" y="771022"/>
+                    <a:pt x="3006988" y="771022"/>
+                  </a:cubicBezTo>
+                  <a:lnTo>
+                    <a:pt x="77102" y="771022"/>
+                  </a:lnTo>
+                  <a:cubicBezTo>
+                    <a:pt x="34520" y="771022"/>
+                    <a:pt x="0" y="736502"/>
+                    <a:pt x="0" y="693920"/>
+                  </a:cubicBezTo>
+                  <a:lnTo>
+                    <a:pt x="0" y="77102"/>
+                  </a:lnTo>
+                  <a:close/>
+                </a:path>
+              </a:pathLst>
+            </a:custGeom>
+          </p:spPr>
+          <p:style>
+            <a:lnRef idx="2">
+              <a:schemeClr val="dk2">
+                <a:alpha val="90000"/>
+                <a:tint val="40000"/>
+                <a:hueOff val="0"/>
+                <a:satOff val="0"/>
+                <a:lumOff val="0"/>
+                <a:alphaOff val="0"/>
+              </a:schemeClr>
+            </a:lnRef>
+            <a:fillRef idx="1">
+              <a:schemeClr val="dk2">
+                <a:alpha val="90000"/>
+                <a:tint val="40000"/>
+                <a:hueOff val="0"/>
+                <a:satOff val="0"/>
+                <a:lumOff val="0"/>
+                <a:alphaOff val="0"/>
+              </a:schemeClr>
+            </a:fillRef>
+            <a:effectRef idx="0">
+              <a:schemeClr val="dk2">
+                <a:alpha val="90000"/>
+                <a:tint val="40000"/>
+                <a:hueOff val="0"/>
+                <a:satOff val="0"/>
+                <a:lumOff val="0"/>
+                <a:alphaOff val="0"/>
+              </a:schemeClr>
+            </a:effectRef>
+            <a:fontRef idx="minor">
+              <a:schemeClr val="dk1">
+                <a:hueOff val="0"/>
+                <a:satOff val="0"/>
+                <a:lumOff val="0"/>
+                <a:alphaOff val="0"/>
+              </a:schemeClr>
+            </a:fontRef>
+          </p:style>
+          <p:txBody>
+            <a:bodyPr spcFirstLastPara="0" vert="horz" wrap="square" lIns="53062" tIns="53062" rIns="53062" bIns="53062" numCol="1" spcCol="1270" anchor="ctr" anchorCtr="0">
+              <a:noAutofit/>
+            </a:bodyPr>
+            <a:lstStyle/>
+            <a:p>
+              <a:pPr marL="0" lvl="0" indent="0" algn="ctr" defTabSz="1066800">
+                <a:lnSpc>
+                  <a:spcPct val="90000"/>
+                </a:lnSpc>
+                <a:spcBef>
+                  <a:spcPct val="0"/>
+                </a:spcBef>
+                <a:spcAft>
+                  <a:spcPct val="35000"/>
+                </a:spcAft>
+                <a:buNone/>
+              </a:pPr>
+              <a:r>
+                <a:rPr lang="en-US" sz="2400" kern="1200" dirty="0"/>
+                <a:t>Grid Search/OLS</a:t>
+              </a:r>
+            </a:p>
+          </p:txBody>
+        </p:sp>
       </p:grpSp>
+      <p:sp>
+        <p:nvSpPr>
+          <p:cNvPr id="7" name="TextBox 6">
+            <a:extLst>
+              <a:ext uri="{FF2B5EF4-FFF2-40B4-BE49-F238E27FC236}">
+                <a16:creationId xmlns:a16="http://schemas.microsoft.com/office/drawing/2014/main" id="{AE2146A0-C579-9B65-4586-5D632A6C93FF}"/>
+              </a:ext>
+            </a:extLst>
+          </p:cNvPr>
+          <p:cNvSpPr txBox="1"/>
+          <p:nvPr/>
+        </p:nvSpPr>
+        <p:spPr>
+          <a:xfrm>
+            <a:off x="107549" y="2657548"/>
+            <a:ext cx="1848135" cy="523220"/>
+          </a:xfrm>
+          <a:prstGeom prst="rect">
+            <a:avLst/>
+          </a:prstGeom>
+          <a:noFill/>
+        </p:spPr>
+        <p:txBody>
+          <a:bodyPr wrap="none" rtlCol="0">
+            <a:spAutoFit/>
+          </a:bodyPr>
+          <a:lstStyle/>
+          <a:p>
+            <a:r>
+              <a:rPr lang="en-US" sz="2800" dirty="0"/>
+              <a:t>Estimation</a:t>
+            </a:r>
+          </a:p>
+        </p:txBody>
+      </p:sp>
+      <p:sp>
+        <p:nvSpPr>
+          <p:cNvPr id="41" name="TextBox 40">
+            <a:extLst>
+              <a:ext uri="{FF2B5EF4-FFF2-40B4-BE49-F238E27FC236}">
+                <a16:creationId xmlns:a16="http://schemas.microsoft.com/office/drawing/2014/main" id="{1CA2B115-65D0-9D77-DB2C-752B37AF275D}"/>
+              </a:ext>
+            </a:extLst>
+          </p:cNvPr>
+          <p:cNvSpPr txBox="1"/>
+          <p:nvPr/>
+        </p:nvSpPr>
+        <p:spPr>
+          <a:xfrm>
+            <a:off x="-112446" y="3677233"/>
+            <a:ext cx="2068130" cy="523220"/>
+          </a:xfrm>
+          <a:prstGeom prst="rect">
+            <a:avLst/>
+          </a:prstGeom>
+          <a:noFill/>
+        </p:spPr>
+        <p:txBody>
+          <a:bodyPr wrap="none" rtlCol="0">
+            <a:spAutoFit/>
+          </a:bodyPr>
+          <a:lstStyle/>
+          <a:p>
+            <a:r>
+              <a:rPr lang="en-US" sz="2800" dirty="0"/>
+              <a:t>Initialization</a:t>
+            </a:r>
+          </a:p>
+        </p:txBody>
+      </p:sp>
     </p:spTree>
     <p:extLst>
       <p:ext uri="{BB962C8B-B14F-4D97-AF65-F5344CB8AC3E}">

</xml_diff>